<commit_message>
Reveal Gapminder marks and channels across four cumulative slides
</commit_message>
<xml_diff>
--- a/lectures/w04-gapminder-marks.pptx
+++ b/lectures/w04-gapminder-marks.pptx
@@ -2,13 +2,16 @@
 <file path=ppt/presentation.xml><?xml version="1.0" encoding="utf-8"?>
 <p:presentation xmlns:p="http://schemas.openxmlformats.org/presentationml/2006/main">
   <p:sldMasterIdLst>
-    <p:sldMasterId xmlns:r="http://schemas.openxmlformats.org/officeDocument/2006/relationships" id="2147483648" r:id="Rd8de31118f6542de"/>
+    <p:sldMasterId xmlns:r="http://schemas.openxmlformats.org/officeDocument/2006/relationships" id="2147483648" r:id="Rad5ecd7077124401"/>
   </p:sldMasterIdLst>
   <p:notesMasterIdLst>
-    <p:notesMasterId xmlns:r="http://schemas.openxmlformats.org/officeDocument/2006/relationships" r:id="R7efc49a2f2254648"/>
+    <p:notesMasterId xmlns:r="http://schemas.openxmlformats.org/officeDocument/2006/relationships" r:id="R95eec572b3fe429f"/>
   </p:notesMasterIdLst>
   <p:sldIdLst>
-    <p:sldId xmlns:r="http://schemas.openxmlformats.org/officeDocument/2006/relationships" id="256" r:id="R3493e42ae3fe489d"/>
+    <p:sldId xmlns:r="http://schemas.openxmlformats.org/officeDocument/2006/relationships" id="256" r:id="R9eede85ca0104653"/>
+    <p:sldId xmlns:r="http://schemas.openxmlformats.org/officeDocument/2006/relationships" id="257" r:id="Racb89a99669947c3"/>
+    <p:sldId xmlns:r="http://schemas.openxmlformats.org/officeDocument/2006/relationships" id="258" r:id="R8f2b4c575eb84ebe"/>
+    <p:sldId xmlns:r="http://schemas.openxmlformats.org/officeDocument/2006/relationships" id="259" r:id="R5f61577c377c4283"/>
   </p:sldIdLst>
   <p:sldSz cx="12192000" cy="6858000"/>
   <p:notesSz cx="6858000" cy="9144000"/>
@@ -472,6 +475,216 @@
 </p:notes>
 </file>
 
+<file path=ppt/notesSlides/notesSlide2.xml><?xml version="1.0" encoding="utf-8"?>
+<p:notes xmlns:p="http://schemas.openxmlformats.org/presentationml/2006/main">
+  <p:cSld>
+    <p:spTree>
+      <p:nvGrpSpPr>
+        <p:cNvPr id="1" name=""/>
+        <p:cNvGrpSpPr/>
+        <p:nvPr/>
+      </p:nvGrpSpPr>
+      <p:grpSpPr>
+        <a:xfrm xmlns:a="http://schemas.openxmlformats.org/drawingml/2006/main"/>
+      </p:grpSpPr>
+      <p:sp>
+        <p:nvSpPr>
+          <p:cNvPr id="2" name="Slide Image Placeholder 1"/>
+          <p:cNvSpPr>
+            <a:spLocks xmlns:a="http://schemas.openxmlformats.org/drawingml/2006/main" noGrp="1"/>
+          </p:cNvSpPr>
+          <p:nvPr>
+            <p:ph type="sldImg" idx="0"/>
+          </p:nvPr>
+        </p:nvSpPr>
+        <p:spPr/>
+      </p:sp>
+      <p:sp>
+        <p:nvSpPr>
+          <p:cNvPr id="3" name="Notes Placeholder 2"/>
+          <p:cNvSpPr>
+            <a:spLocks xmlns:a="http://schemas.openxmlformats.org/drawingml/2006/main" noGrp="1"/>
+          </p:cNvSpPr>
+          <p:nvPr>
+            <p:ph type="body" idx="1"/>
+          </p:nvPr>
+        </p:nvSpPr>
+        <p:spPr/>
+        <p:txBody>
+          <a:bodyPr xmlns:a="http://schemas.openxmlformats.org/drawingml/2006/main"/>
+          <a:lstStyle xmlns:a="http://schemas.openxmlformats.org/drawingml/2006/main"/>
+          <a:p xmlns:a="http://schemas.openxmlformats.org/drawingml/2006/main">
+            <a:r>
+              <a:t>Placed immediately after the Channels introduction, before the Tableau Marks card. Ask: what does one circle represent in our Gapminder chart? At a selected year, one country. First circle is a plain mark with no data encoded. Then map population to circle area, continent to color, and GDP per person and life expectancy to horizontal and vertical position. Each stage retains the preceding channels. The four circles show a schematic encoding sequence, not four different countries or measured numerical values. The placement within the final axes is illustrative, with no numerical ticks. Class data: data/gapminder/hans.csv; fields Country, Year, Population, GDP, Life Expectancy, region. Population maps to area, not radius. Do not interpret the plain starting circle as zero population. Ask which information disappears if all circles share one size or one color.</a:t>
+            </a:r>
+          </a:p>
+        </p:txBody>
+      </p:sp>
+      <p:sp>
+        <p:nvSpPr>
+          <p:cNvPr id="4" name="Slide Number Placeholder 3"/>
+          <p:cNvSpPr>
+            <a:spLocks xmlns:a="http://schemas.openxmlformats.org/drawingml/2006/main" noGrp="1"/>
+          </p:cNvSpPr>
+          <p:nvPr>
+            <p:ph type="sldNum" idx="5"/>
+          </p:nvPr>
+        </p:nvSpPr>
+        <p:spPr/>
+        <p:txBody>
+          <a:bodyPr xmlns:a="http://schemas.openxmlformats.org/drawingml/2006/main"/>
+          <a:lstStyle xmlns:a="http://schemas.openxmlformats.org/drawingml/2006/main"/>
+          <a:p xmlns:a="http://schemas.openxmlformats.org/drawingml/2006/main"/>
+        </p:txBody>
+      </p:sp>
+    </p:spTree>
+  </p:cSld>
+  <p:clrMapOvr>
+    <a:masterClrMapping xmlns:a="http://schemas.openxmlformats.org/drawingml/2006/main"/>
+  </p:clrMapOvr>
+</p:notes>
+</file>
+
+<file path=ppt/notesSlides/notesSlide3.xml><?xml version="1.0" encoding="utf-8"?>
+<p:notes xmlns:p="http://schemas.openxmlformats.org/presentationml/2006/main">
+  <p:cSld>
+    <p:spTree>
+      <p:nvGrpSpPr>
+        <p:cNvPr id="1" name=""/>
+        <p:cNvGrpSpPr/>
+        <p:nvPr/>
+      </p:nvGrpSpPr>
+      <p:grpSpPr>
+        <a:xfrm xmlns:a="http://schemas.openxmlformats.org/drawingml/2006/main"/>
+      </p:grpSpPr>
+      <p:sp>
+        <p:nvSpPr>
+          <p:cNvPr id="2" name="Slide Image Placeholder 1"/>
+          <p:cNvSpPr>
+            <a:spLocks xmlns:a="http://schemas.openxmlformats.org/drawingml/2006/main" noGrp="1"/>
+          </p:cNvSpPr>
+          <p:nvPr>
+            <p:ph type="sldImg" idx="0"/>
+          </p:nvPr>
+        </p:nvSpPr>
+        <p:spPr/>
+      </p:sp>
+      <p:sp>
+        <p:nvSpPr>
+          <p:cNvPr id="3" name="Notes Placeholder 2"/>
+          <p:cNvSpPr>
+            <a:spLocks xmlns:a="http://schemas.openxmlformats.org/drawingml/2006/main" noGrp="1"/>
+          </p:cNvSpPr>
+          <p:nvPr>
+            <p:ph type="body" idx="1"/>
+          </p:nvPr>
+        </p:nvSpPr>
+        <p:spPr/>
+        <p:txBody>
+          <a:bodyPr xmlns:a="http://schemas.openxmlformats.org/drawingml/2006/main"/>
+          <a:lstStyle xmlns:a="http://schemas.openxmlformats.org/drawingml/2006/main"/>
+          <a:p xmlns:a="http://schemas.openxmlformats.org/drawingml/2006/main">
+            <a:r>
+              <a:t>Placed immediately after the Channels introduction, before the Tableau Marks card. Ask: what does one circle represent in our Gapminder chart? At a selected year, one country. First circle is a plain mark with no data encoded. Then map population to circle area, continent to color, and GDP per person and life expectancy to horizontal and vertical position. Each stage retains the preceding channels. The four circles show a schematic encoding sequence, not four different countries or measured numerical values. The placement within the final axes is illustrative, with no numerical ticks. Class data: data/gapminder/hans.csv; fields Country, Year, Population, GDP, Life Expectancy, region. Population maps to area, not radius. Do not interpret the plain starting circle as zero population. Ask which information disappears if all circles share one size or one color.</a:t>
+            </a:r>
+          </a:p>
+        </p:txBody>
+      </p:sp>
+      <p:sp>
+        <p:nvSpPr>
+          <p:cNvPr id="4" name="Slide Number Placeholder 3"/>
+          <p:cNvSpPr>
+            <a:spLocks xmlns:a="http://schemas.openxmlformats.org/drawingml/2006/main" noGrp="1"/>
+          </p:cNvSpPr>
+          <p:nvPr>
+            <p:ph type="sldNum" idx="5"/>
+          </p:nvPr>
+        </p:nvSpPr>
+        <p:spPr/>
+        <p:txBody>
+          <a:bodyPr xmlns:a="http://schemas.openxmlformats.org/drawingml/2006/main"/>
+          <a:lstStyle xmlns:a="http://schemas.openxmlformats.org/drawingml/2006/main"/>
+          <a:p xmlns:a="http://schemas.openxmlformats.org/drawingml/2006/main"/>
+        </p:txBody>
+      </p:sp>
+    </p:spTree>
+  </p:cSld>
+  <p:clrMapOvr>
+    <a:masterClrMapping xmlns:a="http://schemas.openxmlformats.org/drawingml/2006/main"/>
+  </p:clrMapOvr>
+</p:notes>
+</file>
+
+<file path=ppt/notesSlides/notesSlide4.xml><?xml version="1.0" encoding="utf-8"?>
+<p:notes xmlns:p="http://schemas.openxmlformats.org/presentationml/2006/main">
+  <p:cSld>
+    <p:spTree>
+      <p:nvGrpSpPr>
+        <p:cNvPr id="1" name=""/>
+        <p:cNvGrpSpPr/>
+        <p:nvPr/>
+      </p:nvGrpSpPr>
+      <p:grpSpPr>
+        <a:xfrm xmlns:a="http://schemas.openxmlformats.org/drawingml/2006/main"/>
+      </p:grpSpPr>
+      <p:sp>
+        <p:nvSpPr>
+          <p:cNvPr id="2" name="Slide Image Placeholder 1"/>
+          <p:cNvSpPr>
+            <a:spLocks xmlns:a="http://schemas.openxmlformats.org/drawingml/2006/main" noGrp="1"/>
+          </p:cNvSpPr>
+          <p:nvPr>
+            <p:ph type="sldImg" idx="0"/>
+          </p:nvPr>
+        </p:nvSpPr>
+        <p:spPr/>
+      </p:sp>
+      <p:sp>
+        <p:nvSpPr>
+          <p:cNvPr id="3" name="Notes Placeholder 2"/>
+          <p:cNvSpPr>
+            <a:spLocks xmlns:a="http://schemas.openxmlformats.org/drawingml/2006/main" noGrp="1"/>
+          </p:cNvSpPr>
+          <p:nvPr>
+            <p:ph type="body" idx="1"/>
+          </p:nvPr>
+        </p:nvSpPr>
+        <p:spPr/>
+        <p:txBody>
+          <a:bodyPr xmlns:a="http://schemas.openxmlformats.org/drawingml/2006/main"/>
+          <a:lstStyle xmlns:a="http://schemas.openxmlformats.org/drawingml/2006/main"/>
+          <a:p xmlns:a="http://schemas.openxmlformats.org/drawingml/2006/main">
+            <a:r>
+              <a:t>Placed immediately after the Channels introduction, before the Tableau Marks card. Ask: what does one circle represent in our Gapminder chart? At a selected year, one country. First circle is a plain mark with no data encoded. Then map population to circle area, continent to color, and GDP per person and life expectancy to horizontal and vertical position. Each stage retains the preceding channels. The four circles show a schematic encoding sequence, not four different countries or measured numerical values. The placement within the final axes is illustrative, with no numerical ticks. Class data: data/gapminder/hans.csv; fields Country, Year, Population, GDP, Life Expectancy, region. Population maps to area, not radius. Do not interpret the plain starting circle as zero population. Ask which information disappears if all circles share one size or one color.</a:t>
+            </a:r>
+          </a:p>
+        </p:txBody>
+      </p:sp>
+      <p:sp>
+        <p:nvSpPr>
+          <p:cNvPr id="4" name="Slide Number Placeholder 3"/>
+          <p:cNvSpPr>
+            <a:spLocks xmlns:a="http://schemas.openxmlformats.org/drawingml/2006/main" noGrp="1"/>
+          </p:cNvSpPr>
+          <p:nvPr>
+            <p:ph type="sldNum" idx="5"/>
+          </p:nvPr>
+        </p:nvSpPr>
+        <p:spPr/>
+        <p:txBody>
+          <a:bodyPr xmlns:a="http://schemas.openxmlformats.org/drawingml/2006/main"/>
+          <a:lstStyle xmlns:a="http://schemas.openxmlformats.org/drawingml/2006/main"/>
+          <a:p xmlns:a="http://schemas.openxmlformats.org/drawingml/2006/main"/>
+        </p:txBody>
+      </p:sp>
+    </p:spTree>
+  </p:cSld>
+  <p:clrMapOvr>
+    <a:masterClrMapping xmlns:a="http://schemas.openxmlformats.org/drawingml/2006/main"/>
+  </p:clrMapOvr>
+</p:notes>
+</file>
+
 <file path=ppt/slideLayouts/slideLayout1.xml><?xml version="1.0" encoding="utf-8"?>
 <p:sldLayout xmlns:p="http://schemas.openxmlformats.org/presentationml/2006/main" type="title">
   <p:cSld name="Title Slide">
@@ -489,7 +702,7 @@
           <p:cNvPr id="3" name="Title">
             <a:extLst xmlns:a="http://schemas.openxmlformats.org/drawingml/2006/main">
               <a:ext uri="{FF2B5EF4-FFF2-40B4-BE49-F238E27FC236}">
-                <a16:creationId xmlns:a16="http://schemas.microsoft.com/office/drawing/2014/main" id="{ACAB0FAB-8414-448D-9B71-534653E654C7}"/>
+                <a16:creationId xmlns:a16="http://schemas.microsoft.com/office/drawing/2014/main" id="{9CFBE0C0-7BBE-4736-B324-4B10740B1888}"/>
               </a:ext>
             </a:extLst>
           </p:cNvPr>
@@ -646,7 +859,7 @@
           <p:cNvPr id="2" name="Subtitle">
             <a:extLst xmlns:a="http://schemas.openxmlformats.org/drawingml/2006/main">
               <a:ext uri="{FF2B5EF4-FFF2-40B4-BE49-F238E27FC236}">
-                <a16:creationId xmlns:a16="http://schemas.microsoft.com/office/drawing/2014/main" id="{12B15855-92AF-48C0-AE79-477625811673}"/>
+                <a16:creationId xmlns:a16="http://schemas.microsoft.com/office/drawing/2014/main" id="{450FD86A-4938-4778-9085-DCED9563C763}"/>
               </a:ext>
             </a:extLst>
           </p:cNvPr>
@@ -820,7 +1033,7 @@
           <p:cNvPr id="2" name="Section title">
             <a:extLst xmlns:a="http://schemas.openxmlformats.org/drawingml/2006/main">
               <a:ext uri="{FF2B5EF4-FFF2-40B4-BE49-F238E27FC236}">
-                <a16:creationId xmlns:a16="http://schemas.microsoft.com/office/drawing/2014/main" id="{7BFED0F3-628B-4CD3-92B4-35F45B3988E1}"/>
+                <a16:creationId xmlns:a16="http://schemas.microsoft.com/office/drawing/2014/main" id="{FCDE46A5-27A9-4AB6-913D-76EBB0D50EE4}"/>
               </a:ext>
             </a:extLst>
           </p:cNvPr>
@@ -994,7 +1207,7 @@
           <p:cNvPr id="3" name="Title">
             <a:extLst xmlns:a="http://schemas.openxmlformats.org/drawingml/2006/main">
               <a:ext uri="{FF2B5EF4-FFF2-40B4-BE49-F238E27FC236}">
-                <a16:creationId xmlns:a16="http://schemas.microsoft.com/office/drawing/2014/main" id="{4C016F58-61ED-47B2-B162-F9EBC5917C9F}"/>
+                <a16:creationId xmlns:a16="http://schemas.microsoft.com/office/drawing/2014/main" id="{32744FEB-C01C-460E-97F3-E29DFD2E1D34}"/>
               </a:ext>
             </a:extLst>
           </p:cNvPr>
@@ -1151,7 +1364,7 @@
           <p:cNvPr id="2" name="Body">
             <a:extLst xmlns:a="http://schemas.openxmlformats.org/drawingml/2006/main">
               <a:ext uri="{FF2B5EF4-FFF2-40B4-BE49-F238E27FC236}">
-                <a16:creationId xmlns:a16="http://schemas.microsoft.com/office/drawing/2014/main" id="{E6C29781-115C-4932-9007-AFD1D188C983}"/>
+                <a16:creationId xmlns:a16="http://schemas.microsoft.com/office/drawing/2014/main" id="{6E06A3D7-E419-4AE4-8BF4-1860EDBB2778}"/>
               </a:ext>
             </a:extLst>
           </p:cNvPr>
@@ -1325,7 +1538,7 @@
           <p:cNvPr id="4" name="Title">
             <a:extLst xmlns:a="http://schemas.openxmlformats.org/drawingml/2006/main">
               <a:ext uri="{FF2B5EF4-FFF2-40B4-BE49-F238E27FC236}">
-                <a16:creationId xmlns:a16="http://schemas.microsoft.com/office/drawing/2014/main" id="{8D05641C-6EEF-48CF-BC0C-D0C453D93257}"/>
+                <a16:creationId xmlns:a16="http://schemas.microsoft.com/office/drawing/2014/main" id="{E8CBEB29-8D65-4FC3-BA39-8DB5D7FA7A0A}"/>
               </a:ext>
             </a:extLst>
           </p:cNvPr>
@@ -1482,7 +1695,7 @@
           <p:cNvPr id="2" name="Left column">
             <a:extLst xmlns:a="http://schemas.openxmlformats.org/drawingml/2006/main">
               <a:ext uri="{FF2B5EF4-FFF2-40B4-BE49-F238E27FC236}">
-                <a16:creationId xmlns:a16="http://schemas.microsoft.com/office/drawing/2014/main" id="{53C3790C-D668-429B-B822-092AC4EEEAC9}"/>
+                <a16:creationId xmlns:a16="http://schemas.microsoft.com/office/drawing/2014/main" id="{A3FCC7FA-E6E3-4121-8BDC-3ED5F7476B09}"/>
               </a:ext>
             </a:extLst>
           </p:cNvPr>
@@ -1639,7 +1852,7 @@
           <p:cNvPr id="3" name="Right column">
             <a:extLst xmlns:a="http://schemas.openxmlformats.org/drawingml/2006/main">
               <a:ext uri="{FF2B5EF4-FFF2-40B4-BE49-F238E27FC236}">
-                <a16:creationId xmlns:a16="http://schemas.microsoft.com/office/drawing/2014/main" id="{8849701E-8484-4059-8DCA-233D91647B87}"/>
+                <a16:creationId xmlns:a16="http://schemas.microsoft.com/office/drawing/2014/main" id="{6FD555B0-CC7F-46E9-8FD9-830297475D58}"/>
               </a:ext>
             </a:extLst>
           </p:cNvPr>
@@ -1813,7 +2026,7 @@
           <p:cNvPr id="3" name="Title">
             <a:extLst xmlns:a="http://schemas.openxmlformats.org/drawingml/2006/main">
               <a:ext uri="{FF2B5EF4-FFF2-40B4-BE49-F238E27FC236}">
-                <a16:creationId xmlns:a16="http://schemas.microsoft.com/office/drawing/2014/main" id="{4D253CF2-5748-4BA3-A25D-A885FAE4BC07}"/>
+                <a16:creationId xmlns:a16="http://schemas.microsoft.com/office/drawing/2014/main" id="{DA85B316-BCE7-40ED-BD6E-AAD54180A2E0}"/>
               </a:ext>
             </a:extLst>
           </p:cNvPr>
@@ -1970,7 +2183,7 @@
           <p:cNvPr id="2" name="Left column">
             <a:extLst xmlns:a="http://schemas.openxmlformats.org/drawingml/2006/main">
               <a:ext uri="{FF2B5EF4-FFF2-40B4-BE49-F238E27FC236}">
-                <a16:creationId xmlns:a16="http://schemas.microsoft.com/office/drawing/2014/main" id="{B7703F6E-D4C2-40C4-9722-E84B7F02A56A}"/>
+                <a16:creationId xmlns:a16="http://schemas.microsoft.com/office/drawing/2014/main" id="{3B3245BA-9B35-450A-843C-90777E8E18B1}"/>
               </a:ext>
             </a:extLst>
           </p:cNvPr>
@@ -2165,12 +2378,12 @@
   </p:cSld>
   <p:clrMap bg1="lt1" tx1="dk1" bg2="lt2" tx2="dk2" accent1="accent1" accent2="accent2" accent3="accent3" accent4="accent4" accent5="accent5" accent6="accent6" hlink="hlink" folHlink="folHlink"/>
   <p:sldLayoutIdLst>
-    <p:sldLayoutId xmlns:r="http://schemas.openxmlformats.org/officeDocument/2006/relationships" id="2147483649" r:id="Rfe6811690a7f4890"/>
-    <p:sldLayoutId xmlns:r="http://schemas.openxmlformats.org/officeDocument/2006/relationships" id="2147483650" r:id="R5fb1d934f5674e93"/>
-    <p:sldLayoutId xmlns:r="http://schemas.openxmlformats.org/officeDocument/2006/relationships" id="2147483651" r:id="Ra3023764b0d04cf6"/>
-    <p:sldLayoutId xmlns:r="http://schemas.openxmlformats.org/officeDocument/2006/relationships" id="2147483652" r:id="R6965899d0cf54689"/>
-    <p:sldLayoutId xmlns:r="http://schemas.openxmlformats.org/officeDocument/2006/relationships" id="2147483653" r:id="Rd08cc0bbe1844f0c"/>
-    <p:sldLayoutId xmlns:r="http://schemas.openxmlformats.org/officeDocument/2006/relationships" id="2147483654" r:id="R3b04049ff5d94d60"/>
+    <p:sldLayoutId xmlns:r="http://schemas.openxmlformats.org/officeDocument/2006/relationships" id="2147483649" r:id="R37fbcde7043e455f"/>
+    <p:sldLayoutId xmlns:r="http://schemas.openxmlformats.org/officeDocument/2006/relationships" id="2147483650" r:id="R651c1bf4d2364755"/>
+    <p:sldLayoutId xmlns:r="http://schemas.openxmlformats.org/officeDocument/2006/relationships" id="2147483651" r:id="R49b693e3006047cd"/>
+    <p:sldLayoutId xmlns:r="http://schemas.openxmlformats.org/officeDocument/2006/relationships" id="2147483652" r:id="Rb3349a2e4d124f10"/>
+    <p:sldLayoutId xmlns:r="http://schemas.openxmlformats.org/officeDocument/2006/relationships" id="2147483653" r:id="R839816a2768747fc"/>
+    <p:sldLayoutId xmlns:r="http://schemas.openxmlformats.org/officeDocument/2006/relationships" id="2147483654" r:id="Rc6e5c13b2af842c0"/>
   </p:sldLayoutIdLst>
   <p:txStyles>
     <p:titleStyle>
@@ -2718,10 +2931,10 @@
       </p:grpSpPr>
       <p:sp>
         <p:nvSpPr>
-          <p:cNvPr id="19" name="">
+          <p:cNvPr id="6" name="">
             <a:extLst xmlns:a="http://schemas.openxmlformats.org/drawingml/2006/main">
               <a:ext uri="{FF2B5EF4-FFF2-40B4-BE49-F238E27FC236}">
-                <a16:creationId xmlns:a16="http://schemas.microsoft.com/office/drawing/2014/main" id="{02BFD63C-B4DB-4F73-93B7-4B374A174658}"/>
+                <a16:creationId xmlns:a16="http://schemas.microsoft.com/office/drawing/2014/main" id="{879A21BE-FCB9-440A-82A2-B624D1CD355A}"/>
               </a:ext>
             </a:extLst>
           </p:cNvPr>
@@ -2787,7 +3000,7 @@
           <p:cNvPr id="2" name="">
             <a:extLst xmlns:a="http://schemas.openxmlformats.org/drawingml/2006/main">
               <a:ext uri="{FF2B5EF4-FFF2-40B4-BE49-F238E27FC236}">
-                <a16:creationId xmlns:a16="http://schemas.microsoft.com/office/drawing/2014/main" id="{BDC65A3D-8EA7-4B5A-AAF8-0736494320D4}"/>
+                <a16:creationId xmlns:a16="http://schemas.microsoft.com/office/drawing/2014/main" id="{693FF263-B866-40E9-A688-2489646E16C4}"/>
               </a:ext>
             </a:extLst>
           </p:cNvPr>
@@ -2853,7 +3066,7 @@
           <p:cNvPr id="3" name="">
             <a:extLst xmlns:a="http://schemas.openxmlformats.org/drawingml/2006/main">
               <a:ext uri="{FF2B5EF4-FFF2-40B4-BE49-F238E27FC236}">
-                <a16:creationId xmlns:a16="http://schemas.microsoft.com/office/drawing/2014/main" id="{A85D791B-07E0-44EB-9283-049045AE7684}"/>
+                <a16:creationId xmlns:a16="http://schemas.microsoft.com/office/drawing/2014/main" id="{EB7827FE-2447-4960-A925-D9BD8D75C4B1}"/>
               </a:ext>
             </a:extLst>
           </p:cNvPr>
@@ -2883,7 +3096,7 @@
           <p:cNvPr id="4" name="">
             <a:extLst xmlns:a="http://schemas.openxmlformats.org/drawingml/2006/main">
               <a:ext uri="{FF2B5EF4-FFF2-40B4-BE49-F238E27FC236}">
-                <a16:creationId xmlns:a16="http://schemas.microsoft.com/office/drawing/2014/main" id="{1AC20BD5-FFF7-4EE8-8D74-3C7CB178206B}"/>
+                <a16:creationId xmlns:a16="http://schemas.microsoft.com/office/drawing/2014/main" id="{F576F542-2F7E-43B0-B615-099CC6252761}"/>
               </a:ext>
             </a:extLst>
           </p:cNvPr>
@@ -2894,8 +3107,301 @@
         </p:nvSpPr>
         <p:spPr>
           <a:xfrm xmlns:a="http://schemas.openxmlformats.org/drawingml/2006/main">
-            <a:off x="4019550" y="2781300"/>
-            <a:ext cx="914400" cy="914400"/>
+            <a:off x="523875" y="5095875"/>
+            <a:ext cx="2381250" cy="381000"/>
+          </a:xfrm>
+          <a:prstGeom xmlns:a="http://schemas.openxmlformats.org/drawingml/2006/main" prst="rect">
+            <a:avLst/>
+          </a:prstGeom>
+          <a:noFill xmlns:a="http://schemas.openxmlformats.org/drawingml/2006/main"/>
+          <a:ln xmlns:a="http://schemas.openxmlformats.org/drawingml/2006/main" w="0">
+            <a:noFill/>
+          </a:ln>
+        </p:spPr>
+        <p:txBody>
+          <a:bodyPr xmlns:a="http://schemas.openxmlformats.org/drawingml/2006/main" lIns="0" tIns="0" rIns="0" bIns="0"/>
+          <a:lstStyle xmlns:a="http://schemas.openxmlformats.org/drawingml/2006/main">
+            <a:defPPr algn="ctr">
+              <a:defRPr sz="2325">
+                <a:solidFill>
+                  <a:srgbClr val="38332E"/>
+                </a:solidFill>
+                <a:latin typeface="Ubuntu Condensed"/>
+                <a:ea typeface="Ubuntu Condensed"/>
+                <a:cs typeface="Ubuntu Condensed"/>
+              </a:defRPr>
+            </a:defPPr>
+          </a:lstStyle>
+          <a:p xmlns:a="http://schemas.openxmlformats.org/drawingml/2006/main">
+            <a:pPr algn="ctr">
+              <a:defRPr sz="2325">
+                <a:solidFill>
+                  <a:srgbClr val="38332E"/>
+                </a:solidFill>
+                <a:latin typeface="Ubuntu Condensed"/>
+                <a:ea typeface="Ubuntu Condensed"/>
+                <a:cs typeface="Ubuntu Condensed"/>
+              </a:defRPr>
+            </a:pPr>
+            <a:r>
+              <a:rPr sz="2325">
+                <a:solidFill>
+                  <a:srgbClr val="38332E"/>
+                </a:solidFill>
+                <a:latin typeface="Ubuntu Condensed"/>
+                <a:ea typeface="Ubuntu Condensed"/>
+                <a:cs typeface="Ubuntu Condensed"/>
+              </a:rPr>
+              <a:t>Circle</a:t>
+            </a:r>
+          </a:p>
+        </p:txBody>
+      </p:sp>
+      <p:sp>
+        <p:nvSpPr>
+          <p:cNvPr id="5" name="">
+            <a:extLst xmlns:a="http://schemas.openxmlformats.org/drawingml/2006/main">
+              <a:ext uri="{FF2B5EF4-FFF2-40B4-BE49-F238E27FC236}">
+                <a16:creationId xmlns:a16="http://schemas.microsoft.com/office/drawing/2014/main" id="{5EA277BB-FAAF-4218-908C-A4A8C1ACF7BB}"/>
+              </a:ext>
+            </a:extLst>
+          </p:cNvPr>
+          <p:cNvSpPr>
+            <a:spLocks xmlns:a="http://schemas.openxmlformats.org/drawingml/2006/main" noGrp="1"/>
+          </p:cNvSpPr>
+          <p:nvPr/>
+        </p:nvSpPr>
+        <p:spPr>
+          <a:xfrm xmlns:a="http://schemas.openxmlformats.org/drawingml/2006/main">
+            <a:off x="523875" y="5534025"/>
+            <a:ext cx="2381250" cy="685800"/>
+          </a:xfrm>
+          <a:prstGeom xmlns:a="http://schemas.openxmlformats.org/drawingml/2006/main" prst="rect">
+            <a:avLst/>
+          </a:prstGeom>
+          <a:noFill xmlns:a="http://schemas.openxmlformats.org/drawingml/2006/main"/>
+          <a:ln xmlns:a="http://schemas.openxmlformats.org/drawingml/2006/main" w="0">
+            <a:noFill/>
+          </a:ln>
+        </p:spPr>
+        <p:txBody>
+          <a:bodyPr xmlns:a="http://schemas.openxmlformats.org/drawingml/2006/main" lIns="0" tIns="0" rIns="0" bIns="0"/>
+          <a:lstStyle xmlns:a="http://schemas.openxmlformats.org/drawingml/2006/main">
+            <a:defPPr algn="ctr">
+              <a:defRPr sz="1875">
+                <a:solidFill>
+                  <a:srgbClr val="81796F"/>
+                </a:solidFill>
+                <a:latin typeface="Ubuntu Condensed"/>
+                <a:ea typeface="Ubuntu Condensed"/>
+                <a:cs typeface="Ubuntu Condensed"/>
+              </a:defRPr>
+            </a:defPPr>
+          </a:lstStyle>
+          <a:p xmlns:a="http://schemas.openxmlformats.org/drawingml/2006/main">
+            <a:pPr algn="ctr">
+              <a:defRPr sz="1875">
+                <a:solidFill>
+                  <a:srgbClr val="81796F"/>
+                </a:solidFill>
+                <a:latin typeface="Ubuntu Condensed"/>
+                <a:ea typeface="Ubuntu Condensed"/>
+                <a:cs typeface="Ubuntu Condensed"/>
+              </a:defRPr>
+            </a:pPr>
+            <a:r>
+              <a:rPr sz="1875">
+                <a:solidFill>
+                  <a:srgbClr val="81796F"/>
+                </a:solidFill>
+                <a:latin typeface="Ubuntu Condensed"/>
+                <a:ea typeface="Ubuntu Condensed"/>
+                <a:cs typeface="Ubuntu Condensed"/>
+              </a:rPr>
+              <a:t>A mark</a:t>
+            </a:r>
+          </a:p>
+        </p:txBody>
+      </p:sp>
+    </p:spTree>
+    <p:extLst>
+      <p:ext uri="{BB962C8B-B14F-4D97-AF65-F5344CB8AC3E}">
+        <p14:creationId xmlns:p14="http://schemas.microsoft.com/office/powerpoint/2010/main" val="1186099910"/>
+      </p:ext>
+    </p:extLst>
+  </p:cSld>
+</p:sld>
+</file>
+
+<file path=ppt/slides/slide2.xml><?xml version="1.0" encoding="utf-8"?>
+<p:sld xmlns:p="http://schemas.openxmlformats.org/presentationml/2006/main">
+  <p:cSld>
+    <p:bg>
+      <p:bgPr>
+        <a:solidFill xmlns:a="http://schemas.openxmlformats.org/drawingml/2006/main">
+          <a:srgbClr val="FFFFFF"/>
+        </a:solidFill>
+      </p:bgPr>
+    </p:bg>
+    <p:spTree>
+      <p:nvGrpSpPr>
+        <p:cNvPr id="1" name=""/>
+        <p:cNvGrpSpPr/>
+        <p:nvPr/>
+      </p:nvGrpSpPr>
+      <p:grpSpPr>
+        <a:xfrm xmlns:a="http://schemas.openxmlformats.org/drawingml/2006/main"/>
+      </p:grpSpPr>
+      <p:sp>
+        <p:nvSpPr>
+          <p:cNvPr id="9" name="">
+            <a:extLst xmlns:a="http://schemas.openxmlformats.org/drawingml/2006/main">
+              <a:ext uri="{FF2B5EF4-FFF2-40B4-BE49-F238E27FC236}">
+                <a16:creationId xmlns:a16="http://schemas.microsoft.com/office/drawing/2014/main" id="{7648E028-5E12-4D61-B086-240F9F85EC75}"/>
+              </a:ext>
+            </a:extLst>
+          </p:cNvPr>
+          <p:cNvSpPr>
+            <a:spLocks xmlns:a="http://schemas.openxmlformats.org/drawingml/2006/main" noGrp="1"/>
+          </p:cNvSpPr>
+          <p:nvPr/>
+        </p:nvSpPr>
+        <p:spPr>
+          <a:xfrm xmlns:a="http://schemas.openxmlformats.org/drawingml/2006/main">
+            <a:off x="457200" y="361950"/>
+            <a:ext cx="11277600" cy="628650"/>
+          </a:xfrm>
+          <a:prstGeom xmlns:a="http://schemas.openxmlformats.org/drawingml/2006/main" prst="rect">
+            <a:avLst/>
+          </a:prstGeom>
+          <a:noFill xmlns:a="http://schemas.openxmlformats.org/drawingml/2006/main"/>
+          <a:ln xmlns:a="http://schemas.openxmlformats.org/drawingml/2006/main" w="0">
+            <a:noFill/>
+          </a:ln>
+        </p:spPr>
+        <p:txBody>
+          <a:bodyPr xmlns:a="http://schemas.openxmlformats.org/drawingml/2006/main" lIns="0" tIns="0" rIns="0" bIns="0"/>
+          <a:lstStyle xmlns:a="http://schemas.openxmlformats.org/drawingml/2006/main">
+            <a:defPPr>
+              <a:defRPr sz="3600">
+                <a:solidFill>
+                  <a:srgbClr val="38332E"/>
+                </a:solidFill>
+                <a:latin typeface="Ubuntu Condensed"/>
+                <a:ea typeface="Ubuntu Condensed"/>
+                <a:cs typeface="Ubuntu Condensed"/>
+              </a:defRPr>
+            </a:defPPr>
+          </a:lstStyle>
+          <a:p xmlns:a="http://schemas.openxmlformats.org/drawingml/2006/main">
+            <a:pPr>
+              <a:defRPr sz="3600">
+                <a:solidFill>
+                  <a:srgbClr val="38332E"/>
+                </a:solidFill>
+                <a:latin typeface="Ubuntu Condensed"/>
+                <a:ea typeface="Ubuntu Condensed"/>
+                <a:cs typeface="Ubuntu Condensed"/>
+              </a:defRPr>
+            </a:pPr>
+            <a:r>
+              <a:rPr sz="3600">
+                <a:solidFill>
+                  <a:srgbClr val="38332E"/>
+                </a:solidFill>
+                <a:latin typeface="Ubuntu Condensed"/>
+                <a:ea typeface="Ubuntu Condensed"/>
+                <a:cs typeface="Ubuntu Condensed"/>
+              </a:rPr>
+              <a:t>What does a circle represent?</a:t>
+            </a:r>
+          </a:p>
+        </p:txBody>
+      </p:sp>
+      <p:sp>
+        <p:nvSpPr>
+          <p:cNvPr id="2" name="">
+            <a:extLst xmlns:a="http://schemas.openxmlformats.org/drawingml/2006/main">
+              <a:ext uri="{FF2B5EF4-FFF2-40B4-BE49-F238E27FC236}">
+                <a16:creationId xmlns:a16="http://schemas.microsoft.com/office/drawing/2014/main" id="{4AE3DCDE-03AA-4661-86C4-8EA05DA571F0}"/>
+              </a:ext>
+            </a:extLst>
+          </p:cNvPr>
+          <p:cNvSpPr>
+            <a:spLocks xmlns:a="http://schemas.openxmlformats.org/drawingml/2006/main" noGrp="1"/>
+          </p:cNvSpPr>
+          <p:nvPr/>
+        </p:nvSpPr>
+        <p:spPr>
+          <a:xfrm xmlns:a="http://schemas.openxmlformats.org/drawingml/2006/main">
+            <a:off x="457200" y="1085850"/>
+            <a:ext cx="11277600" cy="381000"/>
+          </a:xfrm>
+          <a:prstGeom xmlns:a="http://schemas.openxmlformats.org/drawingml/2006/main" prst="rect">
+            <a:avLst/>
+          </a:prstGeom>
+          <a:noFill xmlns:a="http://schemas.openxmlformats.org/drawingml/2006/main"/>
+          <a:ln xmlns:a="http://schemas.openxmlformats.org/drawingml/2006/main" w="0">
+            <a:noFill/>
+          </a:ln>
+        </p:spPr>
+        <p:txBody>
+          <a:bodyPr xmlns:a="http://schemas.openxmlformats.org/drawingml/2006/main" lIns="0" tIns="0" rIns="0" bIns="0"/>
+          <a:lstStyle xmlns:a="http://schemas.openxmlformats.org/drawingml/2006/main">
+            <a:defPPr>
+              <a:defRPr sz="2025">
+                <a:solidFill>
+                  <a:srgbClr val="81796F"/>
+                </a:solidFill>
+                <a:latin typeface="Ubuntu Condensed"/>
+                <a:ea typeface="Ubuntu Condensed"/>
+                <a:cs typeface="Ubuntu Condensed"/>
+              </a:defRPr>
+            </a:defPPr>
+          </a:lstStyle>
+          <a:p xmlns:a="http://schemas.openxmlformats.org/drawingml/2006/main">
+            <a:pPr>
+              <a:defRPr sz="2025">
+                <a:solidFill>
+                  <a:srgbClr val="81796F"/>
+                </a:solidFill>
+                <a:latin typeface="Ubuntu Condensed"/>
+                <a:ea typeface="Ubuntu Condensed"/>
+                <a:cs typeface="Ubuntu Condensed"/>
+              </a:defRPr>
+            </a:pPr>
+            <a:r>
+              <a:rPr sz="2025">
+                <a:solidFill>
+                  <a:srgbClr val="81796F"/>
+                </a:solidFill>
+                <a:latin typeface="Ubuntu Condensed"/>
+                <a:ea typeface="Ubuntu Condensed"/>
+                <a:cs typeface="Ubuntu Condensed"/>
+              </a:rPr>
+              <a:t>Gapminder: one country, one year</a:t>
+            </a:r>
+          </a:p>
+        </p:txBody>
+      </p:sp>
+      <p:sp>
+        <p:nvSpPr>
+          <p:cNvPr id="3" name="">
+            <a:extLst xmlns:a="http://schemas.openxmlformats.org/drawingml/2006/main">
+              <a:ext uri="{FF2B5EF4-FFF2-40B4-BE49-F238E27FC236}">
+                <a16:creationId xmlns:a16="http://schemas.microsoft.com/office/drawing/2014/main" id="{B3286D37-EE13-435D-A479-298FB1A727B1}"/>
+              </a:ext>
+            </a:extLst>
+          </p:cNvPr>
+          <p:cNvSpPr>
+            <a:spLocks xmlns:a="http://schemas.openxmlformats.org/drawingml/2006/main" noGrp="1"/>
+          </p:cNvSpPr>
+          <p:nvPr/>
+        </p:nvSpPr>
+        <p:spPr>
+          <a:xfrm xmlns:a="http://schemas.openxmlformats.org/drawingml/2006/main">
+            <a:off x="1504950" y="3028950"/>
+            <a:ext cx="419100" cy="419100"/>
           </a:xfrm>
           <a:prstGeom xmlns:a="http://schemas.openxmlformats.org/drawingml/2006/main" prst="ellipse">
             <a:avLst/>
@@ -2910,10 +3416,525 @@
       </p:sp>
       <p:sp>
         <p:nvSpPr>
+          <p:cNvPr id="4" name="">
+            <a:extLst xmlns:a="http://schemas.openxmlformats.org/drawingml/2006/main">
+              <a:ext uri="{FF2B5EF4-FFF2-40B4-BE49-F238E27FC236}">
+                <a16:creationId xmlns:a16="http://schemas.microsoft.com/office/drawing/2014/main" id="{1E515BC6-9593-4805-A485-567C17B2786C}"/>
+              </a:ext>
+            </a:extLst>
+          </p:cNvPr>
+          <p:cNvSpPr>
+            <a:spLocks xmlns:a="http://schemas.openxmlformats.org/drawingml/2006/main" noGrp="1"/>
+          </p:cNvSpPr>
+          <p:nvPr/>
+        </p:nvSpPr>
+        <p:spPr>
+          <a:xfrm xmlns:a="http://schemas.openxmlformats.org/drawingml/2006/main">
+            <a:off x="4019550" y="2781300"/>
+            <a:ext cx="914400" cy="914400"/>
+          </a:xfrm>
+          <a:prstGeom xmlns:a="http://schemas.openxmlformats.org/drawingml/2006/main" prst="ellipse">
+            <a:avLst/>
+          </a:prstGeom>
+          <a:solidFill xmlns:a="http://schemas.openxmlformats.org/drawingml/2006/main">
+            <a:srgbClr val="A6A29C"/>
+          </a:solidFill>
+          <a:ln xmlns:a="http://schemas.openxmlformats.org/drawingml/2006/main" w="0">
+            <a:noFill/>
+          </a:ln>
+        </p:spPr>
+      </p:sp>
+      <p:sp>
+        <p:nvSpPr>
           <p:cNvPr id="5" name="">
             <a:extLst xmlns:a="http://schemas.openxmlformats.org/drawingml/2006/main">
               <a:ext uri="{FF2B5EF4-FFF2-40B4-BE49-F238E27FC236}">
-                <a16:creationId xmlns:a16="http://schemas.microsoft.com/office/drawing/2014/main" id="{6C4F04CC-4106-4218-BAF2-5744E9992EB4}"/>
+                <a16:creationId xmlns:a16="http://schemas.microsoft.com/office/drawing/2014/main" id="{8D517541-1D3A-497E-8DCB-E71370B96EDF}"/>
+              </a:ext>
+            </a:extLst>
+          </p:cNvPr>
+          <p:cNvSpPr>
+            <a:spLocks xmlns:a="http://schemas.openxmlformats.org/drawingml/2006/main" noGrp="1"/>
+          </p:cNvSpPr>
+          <p:nvPr/>
+        </p:nvSpPr>
+        <p:spPr>
+          <a:xfrm xmlns:a="http://schemas.openxmlformats.org/drawingml/2006/main">
+            <a:off x="523875" y="5095875"/>
+            <a:ext cx="2381250" cy="381000"/>
+          </a:xfrm>
+          <a:prstGeom xmlns:a="http://schemas.openxmlformats.org/drawingml/2006/main" prst="rect">
+            <a:avLst/>
+          </a:prstGeom>
+          <a:noFill xmlns:a="http://schemas.openxmlformats.org/drawingml/2006/main"/>
+          <a:ln xmlns:a="http://schemas.openxmlformats.org/drawingml/2006/main" w="0">
+            <a:noFill/>
+          </a:ln>
+        </p:spPr>
+        <p:txBody>
+          <a:bodyPr xmlns:a="http://schemas.openxmlformats.org/drawingml/2006/main" lIns="0" tIns="0" rIns="0" bIns="0"/>
+          <a:lstStyle xmlns:a="http://schemas.openxmlformats.org/drawingml/2006/main">
+            <a:defPPr algn="ctr">
+              <a:defRPr sz="2325">
+                <a:solidFill>
+                  <a:srgbClr val="38332E"/>
+                </a:solidFill>
+                <a:latin typeface="Ubuntu Condensed"/>
+                <a:ea typeface="Ubuntu Condensed"/>
+                <a:cs typeface="Ubuntu Condensed"/>
+              </a:defRPr>
+            </a:defPPr>
+          </a:lstStyle>
+          <a:p xmlns:a="http://schemas.openxmlformats.org/drawingml/2006/main">
+            <a:pPr algn="ctr">
+              <a:defRPr sz="2325">
+                <a:solidFill>
+                  <a:srgbClr val="38332E"/>
+                </a:solidFill>
+                <a:latin typeface="Ubuntu Condensed"/>
+                <a:ea typeface="Ubuntu Condensed"/>
+                <a:cs typeface="Ubuntu Condensed"/>
+              </a:defRPr>
+            </a:pPr>
+            <a:r>
+              <a:rPr sz="2325">
+                <a:solidFill>
+                  <a:srgbClr val="38332E"/>
+                </a:solidFill>
+                <a:latin typeface="Ubuntu Condensed"/>
+                <a:ea typeface="Ubuntu Condensed"/>
+                <a:cs typeface="Ubuntu Condensed"/>
+              </a:rPr>
+              <a:t>Circle</a:t>
+            </a:r>
+          </a:p>
+        </p:txBody>
+      </p:sp>
+      <p:sp>
+        <p:nvSpPr>
+          <p:cNvPr id="6" name="">
+            <a:extLst xmlns:a="http://schemas.openxmlformats.org/drawingml/2006/main">
+              <a:ext uri="{FF2B5EF4-FFF2-40B4-BE49-F238E27FC236}">
+                <a16:creationId xmlns:a16="http://schemas.microsoft.com/office/drawing/2014/main" id="{020B7C0A-9210-4C8A-B8F2-1AE67063F1FA}"/>
+              </a:ext>
+            </a:extLst>
+          </p:cNvPr>
+          <p:cNvSpPr>
+            <a:spLocks xmlns:a="http://schemas.openxmlformats.org/drawingml/2006/main" noGrp="1"/>
+          </p:cNvSpPr>
+          <p:nvPr/>
+        </p:nvSpPr>
+        <p:spPr>
+          <a:xfrm xmlns:a="http://schemas.openxmlformats.org/drawingml/2006/main">
+            <a:off x="523875" y="5534025"/>
+            <a:ext cx="2381250" cy="685800"/>
+          </a:xfrm>
+          <a:prstGeom xmlns:a="http://schemas.openxmlformats.org/drawingml/2006/main" prst="rect">
+            <a:avLst/>
+          </a:prstGeom>
+          <a:noFill xmlns:a="http://schemas.openxmlformats.org/drawingml/2006/main"/>
+          <a:ln xmlns:a="http://schemas.openxmlformats.org/drawingml/2006/main" w="0">
+            <a:noFill/>
+          </a:ln>
+        </p:spPr>
+        <p:txBody>
+          <a:bodyPr xmlns:a="http://schemas.openxmlformats.org/drawingml/2006/main" lIns="0" tIns="0" rIns="0" bIns="0"/>
+          <a:lstStyle xmlns:a="http://schemas.openxmlformats.org/drawingml/2006/main">
+            <a:defPPr algn="ctr">
+              <a:defRPr sz="1875">
+                <a:solidFill>
+                  <a:srgbClr val="81796F"/>
+                </a:solidFill>
+                <a:latin typeface="Ubuntu Condensed"/>
+                <a:ea typeface="Ubuntu Condensed"/>
+                <a:cs typeface="Ubuntu Condensed"/>
+              </a:defRPr>
+            </a:defPPr>
+          </a:lstStyle>
+          <a:p xmlns:a="http://schemas.openxmlformats.org/drawingml/2006/main">
+            <a:pPr algn="ctr">
+              <a:defRPr sz="1875">
+                <a:solidFill>
+                  <a:srgbClr val="81796F"/>
+                </a:solidFill>
+                <a:latin typeface="Ubuntu Condensed"/>
+                <a:ea typeface="Ubuntu Condensed"/>
+                <a:cs typeface="Ubuntu Condensed"/>
+              </a:defRPr>
+            </a:pPr>
+            <a:r>
+              <a:rPr sz="1875">
+                <a:solidFill>
+                  <a:srgbClr val="81796F"/>
+                </a:solidFill>
+                <a:latin typeface="Ubuntu Condensed"/>
+                <a:ea typeface="Ubuntu Condensed"/>
+                <a:cs typeface="Ubuntu Condensed"/>
+              </a:rPr>
+              <a:t>A mark</a:t>
+            </a:r>
+          </a:p>
+        </p:txBody>
+      </p:sp>
+      <p:sp>
+        <p:nvSpPr>
+          <p:cNvPr id="7" name="">
+            <a:extLst xmlns:a="http://schemas.openxmlformats.org/drawingml/2006/main">
+              <a:ext uri="{FF2B5EF4-FFF2-40B4-BE49-F238E27FC236}">
+                <a16:creationId xmlns:a16="http://schemas.microsoft.com/office/drawing/2014/main" id="{F9520BAE-3BAC-4797-AFDA-7613C318A9FE}"/>
+              </a:ext>
+            </a:extLst>
+          </p:cNvPr>
+          <p:cNvSpPr>
+            <a:spLocks xmlns:a="http://schemas.openxmlformats.org/drawingml/2006/main" noGrp="1"/>
+          </p:cNvSpPr>
+          <p:nvPr/>
+        </p:nvSpPr>
+        <p:spPr>
+          <a:xfrm xmlns:a="http://schemas.openxmlformats.org/drawingml/2006/main">
+            <a:off x="3333750" y="5095875"/>
+            <a:ext cx="2381250" cy="381000"/>
+          </a:xfrm>
+          <a:prstGeom xmlns:a="http://schemas.openxmlformats.org/drawingml/2006/main" prst="rect">
+            <a:avLst/>
+          </a:prstGeom>
+          <a:noFill xmlns:a="http://schemas.openxmlformats.org/drawingml/2006/main"/>
+          <a:ln xmlns:a="http://schemas.openxmlformats.org/drawingml/2006/main" w="0">
+            <a:noFill/>
+          </a:ln>
+        </p:spPr>
+        <p:txBody>
+          <a:bodyPr xmlns:a="http://schemas.openxmlformats.org/drawingml/2006/main" lIns="0" tIns="0" rIns="0" bIns="0"/>
+          <a:lstStyle xmlns:a="http://schemas.openxmlformats.org/drawingml/2006/main">
+            <a:defPPr algn="ctr">
+              <a:defRPr sz="2325">
+                <a:solidFill>
+                  <a:srgbClr val="38332E"/>
+                </a:solidFill>
+                <a:latin typeface="Ubuntu Condensed"/>
+                <a:ea typeface="Ubuntu Condensed"/>
+                <a:cs typeface="Ubuntu Condensed"/>
+              </a:defRPr>
+            </a:defPPr>
+          </a:lstStyle>
+          <a:p xmlns:a="http://schemas.openxmlformats.org/drawingml/2006/main">
+            <a:pPr algn="ctr">
+              <a:defRPr sz="2325">
+                <a:solidFill>
+                  <a:srgbClr val="38332E"/>
+                </a:solidFill>
+                <a:latin typeface="Ubuntu Condensed"/>
+                <a:ea typeface="Ubuntu Condensed"/>
+                <a:cs typeface="Ubuntu Condensed"/>
+              </a:defRPr>
+            </a:pPr>
+            <a:r>
+              <a:rPr sz="2325">
+                <a:solidFill>
+                  <a:srgbClr val="38332E"/>
+                </a:solidFill>
+                <a:latin typeface="Ubuntu Condensed"/>
+                <a:ea typeface="Ubuntu Condensed"/>
+                <a:cs typeface="Ubuntu Condensed"/>
+              </a:rPr>
+              <a:t>Area</a:t>
+            </a:r>
+          </a:p>
+        </p:txBody>
+      </p:sp>
+      <p:sp>
+        <p:nvSpPr>
+          <p:cNvPr id="8" name="">
+            <a:extLst xmlns:a="http://schemas.openxmlformats.org/drawingml/2006/main">
+              <a:ext uri="{FF2B5EF4-FFF2-40B4-BE49-F238E27FC236}">
+                <a16:creationId xmlns:a16="http://schemas.microsoft.com/office/drawing/2014/main" id="{98E05D21-33A5-454C-8B03-7B224EE6B78D}"/>
+              </a:ext>
+            </a:extLst>
+          </p:cNvPr>
+          <p:cNvSpPr>
+            <a:spLocks xmlns:a="http://schemas.openxmlformats.org/drawingml/2006/main" noGrp="1"/>
+          </p:cNvSpPr>
+          <p:nvPr/>
+        </p:nvSpPr>
+        <p:spPr>
+          <a:xfrm xmlns:a="http://schemas.openxmlformats.org/drawingml/2006/main">
+            <a:off x="3333750" y="5534025"/>
+            <a:ext cx="2381250" cy="685800"/>
+          </a:xfrm>
+          <a:prstGeom xmlns:a="http://schemas.openxmlformats.org/drawingml/2006/main" prst="rect">
+            <a:avLst/>
+          </a:prstGeom>
+          <a:noFill xmlns:a="http://schemas.openxmlformats.org/drawingml/2006/main"/>
+          <a:ln xmlns:a="http://schemas.openxmlformats.org/drawingml/2006/main" w="0">
+            <a:noFill/>
+          </a:ln>
+        </p:spPr>
+        <p:txBody>
+          <a:bodyPr xmlns:a="http://schemas.openxmlformats.org/drawingml/2006/main" lIns="0" tIns="0" rIns="0" bIns="0"/>
+          <a:lstStyle xmlns:a="http://schemas.openxmlformats.org/drawingml/2006/main">
+            <a:defPPr algn="ctr">
+              <a:defRPr sz="1875">
+                <a:solidFill>
+                  <a:srgbClr val="81796F"/>
+                </a:solidFill>
+                <a:latin typeface="Ubuntu Condensed"/>
+                <a:ea typeface="Ubuntu Condensed"/>
+                <a:cs typeface="Ubuntu Condensed"/>
+              </a:defRPr>
+            </a:defPPr>
+          </a:lstStyle>
+          <a:p xmlns:a="http://schemas.openxmlformats.org/drawingml/2006/main">
+            <a:pPr algn="ctr">
+              <a:defRPr sz="1875">
+                <a:solidFill>
+                  <a:srgbClr val="81796F"/>
+                </a:solidFill>
+                <a:latin typeface="Ubuntu Condensed"/>
+                <a:ea typeface="Ubuntu Condensed"/>
+                <a:cs typeface="Ubuntu Condensed"/>
+              </a:defRPr>
+            </a:pPr>
+            <a:r>
+              <a:rPr sz="1875">
+                <a:solidFill>
+                  <a:srgbClr val="81796F"/>
+                </a:solidFill>
+                <a:latin typeface="Ubuntu Condensed"/>
+                <a:ea typeface="Ubuntu Condensed"/>
+                <a:cs typeface="Ubuntu Condensed"/>
+              </a:rPr>
+              <a:t>Population</a:t>
+            </a:r>
+          </a:p>
+        </p:txBody>
+      </p:sp>
+    </p:spTree>
+    <p:extLst>
+      <p:ext uri="{BB962C8B-B14F-4D97-AF65-F5344CB8AC3E}">
+        <p14:creationId xmlns:p14="http://schemas.microsoft.com/office/powerpoint/2010/main" val="143596029"/>
+      </p:ext>
+    </p:extLst>
+  </p:cSld>
+</p:sld>
+</file>
+
+<file path=ppt/slides/slide3.xml><?xml version="1.0" encoding="utf-8"?>
+<p:sld xmlns:p="http://schemas.openxmlformats.org/presentationml/2006/main">
+  <p:cSld>
+    <p:bg>
+      <p:bgPr>
+        <a:solidFill xmlns:a="http://schemas.openxmlformats.org/drawingml/2006/main">
+          <a:srgbClr val="FFFFFF"/>
+        </a:solidFill>
+      </p:bgPr>
+    </p:bg>
+    <p:spTree>
+      <p:nvGrpSpPr>
+        <p:cNvPr id="1" name=""/>
+        <p:cNvGrpSpPr/>
+        <p:nvPr/>
+      </p:nvGrpSpPr>
+      <p:grpSpPr>
+        <a:xfrm xmlns:a="http://schemas.openxmlformats.org/drawingml/2006/main"/>
+      </p:grpSpPr>
+      <p:sp>
+        <p:nvSpPr>
+          <p:cNvPr id="12" name="">
+            <a:extLst xmlns:a="http://schemas.openxmlformats.org/drawingml/2006/main">
+              <a:ext uri="{FF2B5EF4-FFF2-40B4-BE49-F238E27FC236}">
+                <a16:creationId xmlns:a16="http://schemas.microsoft.com/office/drawing/2014/main" id="{4FF851F1-181D-4D53-B4DD-BDC2299C142B}"/>
+              </a:ext>
+            </a:extLst>
+          </p:cNvPr>
+          <p:cNvSpPr>
+            <a:spLocks xmlns:a="http://schemas.openxmlformats.org/drawingml/2006/main" noGrp="1"/>
+          </p:cNvSpPr>
+          <p:nvPr/>
+        </p:nvSpPr>
+        <p:spPr>
+          <a:xfrm xmlns:a="http://schemas.openxmlformats.org/drawingml/2006/main">
+            <a:off x="457200" y="361950"/>
+            <a:ext cx="11277600" cy="628650"/>
+          </a:xfrm>
+          <a:prstGeom xmlns:a="http://schemas.openxmlformats.org/drawingml/2006/main" prst="rect">
+            <a:avLst/>
+          </a:prstGeom>
+          <a:noFill xmlns:a="http://schemas.openxmlformats.org/drawingml/2006/main"/>
+          <a:ln xmlns:a="http://schemas.openxmlformats.org/drawingml/2006/main" w="0">
+            <a:noFill/>
+          </a:ln>
+        </p:spPr>
+        <p:txBody>
+          <a:bodyPr xmlns:a="http://schemas.openxmlformats.org/drawingml/2006/main" lIns="0" tIns="0" rIns="0" bIns="0"/>
+          <a:lstStyle xmlns:a="http://schemas.openxmlformats.org/drawingml/2006/main">
+            <a:defPPr>
+              <a:defRPr sz="3600">
+                <a:solidFill>
+                  <a:srgbClr val="38332E"/>
+                </a:solidFill>
+                <a:latin typeface="Ubuntu Condensed"/>
+                <a:ea typeface="Ubuntu Condensed"/>
+                <a:cs typeface="Ubuntu Condensed"/>
+              </a:defRPr>
+            </a:defPPr>
+          </a:lstStyle>
+          <a:p xmlns:a="http://schemas.openxmlformats.org/drawingml/2006/main">
+            <a:pPr>
+              <a:defRPr sz="3600">
+                <a:solidFill>
+                  <a:srgbClr val="38332E"/>
+                </a:solidFill>
+                <a:latin typeface="Ubuntu Condensed"/>
+                <a:ea typeface="Ubuntu Condensed"/>
+                <a:cs typeface="Ubuntu Condensed"/>
+              </a:defRPr>
+            </a:pPr>
+            <a:r>
+              <a:rPr sz="3600">
+                <a:solidFill>
+                  <a:srgbClr val="38332E"/>
+                </a:solidFill>
+                <a:latin typeface="Ubuntu Condensed"/>
+                <a:ea typeface="Ubuntu Condensed"/>
+                <a:cs typeface="Ubuntu Condensed"/>
+              </a:rPr>
+              <a:t>What does a circle represent?</a:t>
+            </a:r>
+          </a:p>
+        </p:txBody>
+      </p:sp>
+      <p:sp>
+        <p:nvSpPr>
+          <p:cNvPr id="2" name="">
+            <a:extLst xmlns:a="http://schemas.openxmlformats.org/drawingml/2006/main">
+              <a:ext uri="{FF2B5EF4-FFF2-40B4-BE49-F238E27FC236}">
+                <a16:creationId xmlns:a16="http://schemas.microsoft.com/office/drawing/2014/main" id="{897B04C7-12B6-49BF-B2E0-71017F347B72}"/>
+              </a:ext>
+            </a:extLst>
+          </p:cNvPr>
+          <p:cNvSpPr>
+            <a:spLocks xmlns:a="http://schemas.openxmlformats.org/drawingml/2006/main" noGrp="1"/>
+          </p:cNvSpPr>
+          <p:nvPr/>
+        </p:nvSpPr>
+        <p:spPr>
+          <a:xfrm xmlns:a="http://schemas.openxmlformats.org/drawingml/2006/main">
+            <a:off x="457200" y="1085850"/>
+            <a:ext cx="11277600" cy="381000"/>
+          </a:xfrm>
+          <a:prstGeom xmlns:a="http://schemas.openxmlformats.org/drawingml/2006/main" prst="rect">
+            <a:avLst/>
+          </a:prstGeom>
+          <a:noFill xmlns:a="http://schemas.openxmlformats.org/drawingml/2006/main"/>
+          <a:ln xmlns:a="http://schemas.openxmlformats.org/drawingml/2006/main" w="0">
+            <a:noFill/>
+          </a:ln>
+        </p:spPr>
+        <p:txBody>
+          <a:bodyPr xmlns:a="http://schemas.openxmlformats.org/drawingml/2006/main" lIns="0" tIns="0" rIns="0" bIns="0"/>
+          <a:lstStyle xmlns:a="http://schemas.openxmlformats.org/drawingml/2006/main">
+            <a:defPPr>
+              <a:defRPr sz="2025">
+                <a:solidFill>
+                  <a:srgbClr val="81796F"/>
+                </a:solidFill>
+                <a:latin typeface="Ubuntu Condensed"/>
+                <a:ea typeface="Ubuntu Condensed"/>
+                <a:cs typeface="Ubuntu Condensed"/>
+              </a:defRPr>
+            </a:defPPr>
+          </a:lstStyle>
+          <a:p xmlns:a="http://schemas.openxmlformats.org/drawingml/2006/main">
+            <a:pPr>
+              <a:defRPr sz="2025">
+                <a:solidFill>
+                  <a:srgbClr val="81796F"/>
+                </a:solidFill>
+                <a:latin typeface="Ubuntu Condensed"/>
+                <a:ea typeface="Ubuntu Condensed"/>
+                <a:cs typeface="Ubuntu Condensed"/>
+              </a:defRPr>
+            </a:pPr>
+            <a:r>
+              <a:rPr sz="2025">
+                <a:solidFill>
+                  <a:srgbClr val="81796F"/>
+                </a:solidFill>
+                <a:latin typeface="Ubuntu Condensed"/>
+                <a:ea typeface="Ubuntu Condensed"/>
+                <a:cs typeface="Ubuntu Condensed"/>
+              </a:rPr>
+              <a:t>Gapminder: one country, one year</a:t>
+            </a:r>
+          </a:p>
+        </p:txBody>
+      </p:sp>
+      <p:sp>
+        <p:nvSpPr>
+          <p:cNvPr id="3" name="">
+            <a:extLst xmlns:a="http://schemas.openxmlformats.org/drawingml/2006/main">
+              <a:ext uri="{FF2B5EF4-FFF2-40B4-BE49-F238E27FC236}">
+                <a16:creationId xmlns:a16="http://schemas.microsoft.com/office/drawing/2014/main" id="{BD968307-A3BD-42FD-BDA2-AEC5BBEBC25A}"/>
+              </a:ext>
+            </a:extLst>
+          </p:cNvPr>
+          <p:cNvSpPr>
+            <a:spLocks xmlns:a="http://schemas.openxmlformats.org/drawingml/2006/main" noGrp="1"/>
+          </p:cNvSpPr>
+          <p:nvPr/>
+        </p:nvSpPr>
+        <p:spPr>
+          <a:xfrm xmlns:a="http://schemas.openxmlformats.org/drawingml/2006/main">
+            <a:off x="1504950" y="3028950"/>
+            <a:ext cx="419100" cy="419100"/>
+          </a:xfrm>
+          <a:prstGeom xmlns:a="http://schemas.openxmlformats.org/drawingml/2006/main" prst="ellipse">
+            <a:avLst/>
+          </a:prstGeom>
+          <a:solidFill xmlns:a="http://schemas.openxmlformats.org/drawingml/2006/main">
+            <a:srgbClr val="A6A29C"/>
+          </a:solidFill>
+          <a:ln xmlns:a="http://schemas.openxmlformats.org/drawingml/2006/main" w="0">
+            <a:noFill/>
+          </a:ln>
+        </p:spPr>
+      </p:sp>
+      <p:sp>
+        <p:nvSpPr>
+          <p:cNvPr id="4" name="">
+            <a:extLst xmlns:a="http://schemas.openxmlformats.org/drawingml/2006/main">
+              <a:ext uri="{FF2B5EF4-FFF2-40B4-BE49-F238E27FC236}">
+                <a16:creationId xmlns:a16="http://schemas.microsoft.com/office/drawing/2014/main" id="{A559D2F6-CBC5-4262-9292-3E656BB5D50A}"/>
+              </a:ext>
+            </a:extLst>
+          </p:cNvPr>
+          <p:cNvSpPr>
+            <a:spLocks xmlns:a="http://schemas.openxmlformats.org/drawingml/2006/main" noGrp="1"/>
+          </p:cNvSpPr>
+          <p:nvPr/>
+        </p:nvSpPr>
+        <p:spPr>
+          <a:xfrm xmlns:a="http://schemas.openxmlformats.org/drawingml/2006/main">
+            <a:off x="4019550" y="2781300"/>
+            <a:ext cx="914400" cy="914400"/>
+          </a:xfrm>
+          <a:prstGeom xmlns:a="http://schemas.openxmlformats.org/drawingml/2006/main" prst="ellipse">
+            <a:avLst/>
+          </a:prstGeom>
+          <a:solidFill xmlns:a="http://schemas.openxmlformats.org/drawingml/2006/main">
+            <a:srgbClr val="A6A29C"/>
+          </a:solidFill>
+          <a:ln xmlns:a="http://schemas.openxmlformats.org/drawingml/2006/main" w="0">
+            <a:noFill/>
+          </a:ln>
+        </p:spPr>
+      </p:sp>
+      <p:sp>
+        <p:nvSpPr>
+          <p:cNvPr id="5" name="">
+            <a:extLst xmlns:a="http://schemas.openxmlformats.org/drawingml/2006/main">
+              <a:ext uri="{FF2B5EF4-FFF2-40B4-BE49-F238E27FC236}">
+                <a16:creationId xmlns:a16="http://schemas.microsoft.com/office/drawing/2014/main" id="{F6309FA3-3AF1-4119-8196-71A7CF68E2C6}"/>
               </a:ext>
             </a:extLst>
           </p:cNvPr>
@@ -2943,7 +3964,654 @@
           <p:cNvPr id="6" name="">
             <a:extLst xmlns:a="http://schemas.openxmlformats.org/drawingml/2006/main">
               <a:ext uri="{FF2B5EF4-FFF2-40B4-BE49-F238E27FC236}">
-                <a16:creationId xmlns:a16="http://schemas.microsoft.com/office/drawing/2014/main" id="{B76A71E8-AC09-4825-86C8-61B83C67870F}"/>
+                <a16:creationId xmlns:a16="http://schemas.microsoft.com/office/drawing/2014/main" id="{5D407CF7-C64A-4005-A0CB-04162ACDE246}"/>
+              </a:ext>
+            </a:extLst>
+          </p:cNvPr>
+          <p:cNvSpPr>
+            <a:spLocks xmlns:a="http://schemas.openxmlformats.org/drawingml/2006/main" noGrp="1"/>
+          </p:cNvSpPr>
+          <p:nvPr/>
+        </p:nvSpPr>
+        <p:spPr>
+          <a:xfrm xmlns:a="http://schemas.openxmlformats.org/drawingml/2006/main">
+            <a:off x="523875" y="5095875"/>
+            <a:ext cx="2381250" cy="381000"/>
+          </a:xfrm>
+          <a:prstGeom xmlns:a="http://schemas.openxmlformats.org/drawingml/2006/main" prst="rect">
+            <a:avLst/>
+          </a:prstGeom>
+          <a:noFill xmlns:a="http://schemas.openxmlformats.org/drawingml/2006/main"/>
+          <a:ln xmlns:a="http://schemas.openxmlformats.org/drawingml/2006/main" w="0">
+            <a:noFill/>
+          </a:ln>
+        </p:spPr>
+        <p:txBody>
+          <a:bodyPr xmlns:a="http://schemas.openxmlformats.org/drawingml/2006/main" lIns="0" tIns="0" rIns="0" bIns="0"/>
+          <a:lstStyle xmlns:a="http://schemas.openxmlformats.org/drawingml/2006/main">
+            <a:defPPr algn="ctr">
+              <a:defRPr sz="2325">
+                <a:solidFill>
+                  <a:srgbClr val="38332E"/>
+                </a:solidFill>
+                <a:latin typeface="Ubuntu Condensed"/>
+                <a:ea typeface="Ubuntu Condensed"/>
+                <a:cs typeface="Ubuntu Condensed"/>
+              </a:defRPr>
+            </a:defPPr>
+          </a:lstStyle>
+          <a:p xmlns:a="http://schemas.openxmlformats.org/drawingml/2006/main">
+            <a:pPr algn="ctr">
+              <a:defRPr sz="2325">
+                <a:solidFill>
+                  <a:srgbClr val="38332E"/>
+                </a:solidFill>
+                <a:latin typeface="Ubuntu Condensed"/>
+                <a:ea typeface="Ubuntu Condensed"/>
+                <a:cs typeface="Ubuntu Condensed"/>
+              </a:defRPr>
+            </a:pPr>
+            <a:r>
+              <a:rPr sz="2325">
+                <a:solidFill>
+                  <a:srgbClr val="38332E"/>
+                </a:solidFill>
+                <a:latin typeface="Ubuntu Condensed"/>
+                <a:ea typeface="Ubuntu Condensed"/>
+                <a:cs typeface="Ubuntu Condensed"/>
+              </a:rPr>
+              <a:t>Circle</a:t>
+            </a:r>
+          </a:p>
+        </p:txBody>
+      </p:sp>
+      <p:sp>
+        <p:nvSpPr>
+          <p:cNvPr id="7" name="">
+            <a:extLst xmlns:a="http://schemas.openxmlformats.org/drawingml/2006/main">
+              <a:ext uri="{FF2B5EF4-FFF2-40B4-BE49-F238E27FC236}">
+                <a16:creationId xmlns:a16="http://schemas.microsoft.com/office/drawing/2014/main" id="{4FC347E8-707F-45E6-83EB-E117D8B4CEC1}"/>
+              </a:ext>
+            </a:extLst>
+          </p:cNvPr>
+          <p:cNvSpPr>
+            <a:spLocks xmlns:a="http://schemas.openxmlformats.org/drawingml/2006/main" noGrp="1"/>
+          </p:cNvSpPr>
+          <p:nvPr/>
+        </p:nvSpPr>
+        <p:spPr>
+          <a:xfrm xmlns:a="http://schemas.openxmlformats.org/drawingml/2006/main">
+            <a:off x="523875" y="5534025"/>
+            <a:ext cx="2381250" cy="685800"/>
+          </a:xfrm>
+          <a:prstGeom xmlns:a="http://schemas.openxmlformats.org/drawingml/2006/main" prst="rect">
+            <a:avLst/>
+          </a:prstGeom>
+          <a:noFill xmlns:a="http://schemas.openxmlformats.org/drawingml/2006/main"/>
+          <a:ln xmlns:a="http://schemas.openxmlformats.org/drawingml/2006/main" w="0">
+            <a:noFill/>
+          </a:ln>
+        </p:spPr>
+        <p:txBody>
+          <a:bodyPr xmlns:a="http://schemas.openxmlformats.org/drawingml/2006/main" lIns="0" tIns="0" rIns="0" bIns="0"/>
+          <a:lstStyle xmlns:a="http://schemas.openxmlformats.org/drawingml/2006/main">
+            <a:defPPr algn="ctr">
+              <a:defRPr sz="1875">
+                <a:solidFill>
+                  <a:srgbClr val="81796F"/>
+                </a:solidFill>
+                <a:latin typeface="Ubuntu Condensed"/>
+                <a:ea typeface="Ubuntu Condensed"/>
+                <a:cs typeface="Ubuntu Condensed"/>
+              </a:defRPr>
+            </a:defPPr>
+          </a:lstStyle>
+          <a:p xmlns:a="http://schemas.openxmlformats.org/drawingml/2006/main">
+            <a:pPr algn="ctr">
+              <a:defRPr sz="1875">
+                <a:solidFill>
+                  <a:srgbClr val="81796F"/>
+                </a:solidFill>
+                <a:latin typeface="Ubuntu Condensed"/>
+                <a:ea typeface="Ubuntu Condensed"/>
+                <a:cs typeface="Ubuntu Condensed"/>
+              </a:defRPr>
+            </a:pPr>
+            <a:r>
+              <a:rPr sz="1875">
+                <a:solidFill>
+                  <a:srgbClr val="81796F"/>
+                </a:solidFill>
+                <a:latin typeface="Ubuntu Condensed"/>
+                <a:ea typeface="Ubuntu Condensed"/>
+                <a:cs typeface="Ubuntu Condensed"/>
+              </a:rPr>
+              <a:t>A mark</a:t>
+            </a:r>
+          </a:p>
+        </p:txBody>
+      </p:sp>
+      <p:sp>
+        <p:nvSpPr>
+          <p:cNvPr id="8" name="">
+            <a:extLst xmlns:a="http://schemas.openxmlformats.org/drawingml/2006/main">
+              <a:ext uri="{FF2B5EF4-FFF2-40B4-BE49-F238E27FC236}">
+                <a16:creationId xmlns:a16="http://schemas.microsoft.com/office/drawing/2014/main" id="{0509BE3C-4B06-4D9D-AA0F-D7C67C87288F}"/>
+              </a:ext>
+            </a:extLst>
+          </p:cNvPr>
+          <p:cNvSpPr>
+            <a:spLocks xmlns:a="http://schemas.openxmlformats.org/drawingml/2006/main" noGrp="1"/>
+          </p:cNvSpPr>
+          <p:nvPr/>
+        </p:nvSpPr>
+        <p:spPr>
+          <a:xfrm xmlns:a="http://schemas.openxmlformats.org/drawingml/2006/main">
+            <a:off x="3333750" y="5095875"/>
+            <a:ext cx="2381250" cy="381000"/>
+          </a:xfrm>
+          <a:prstGeom xmlns:a="http://schemas.openxmlformats.org/drawingml/2006/main" prst="rect">
+            <a:avLst/>
+          </a:prstGeom>
+          <a:noFill xmlns:a="http://schemas.openxmlformats.org/drawingml/2006/main"/>
+          <a:ln xmlns:a="http://schemas.openxmlformats.org/drawingml/2006/main" w="0">
+            <a:noFill/>
+          </a:ln>
+        </p:spPr>
+        <p:txBody>
+          <a:bodyPr xmlns:a="http://schemas.openxmlformats.org/drawingml/2006/main" lIns="0" tIns="0" rIns="0" bIns="0"/>
+          <a:lstStyle xmlns:a="http://schemas.openxmlformats.org/drawingml/2006/main">
+            <a:defPPr algn="ctr">
+              <a:defRPr sz="2325">
+                <a:solidFill>
+                  <a:srgbClr val="38332E"/>
+                </a:solidFill>
+                <a:latin typeface="Ubuntu Condensed"/>
+                <a:ea typeface="Ubuntu Condensed"/>
+                <a:cs typeface="Ubuntu Condensed"/>
+              </a:defRPr>
+            </a:defPPr>
+          </a:lstStyle>
+          <a:p xmlns:a="http://schemas.openxmlformats.org/drawingml/2006/main">
+            <a:pPr algn="ctr">
+              <a:defRPr sz="2325">
+                <a:solidFill>
+                  <a:srgbClr val="38332E"/>
+                </a:solidFill>
+                <a:latin typeface="Ubuntu Condensed"/>
+                <a:ea typeface="Ubuntu Condensed"/>
+                <a:cs typeface="Ubuntu Condensed"/>
+              </a:defRPr>
+            </a:pPr>
+            <a:r>
+              <a:rPr sz="2325">
+                <a:solidFill>
+                  <a:srgbClr val="38332E"/>
+                </a:solidFill>
+                <a:latin typeface="Ubuntu Condensed"/>
+                <a:ea typeface="Ubuntu Condensed"/>
+                <a:cs typeface="Ubuntu Condensed"/>
+              </a:rPr>
+              <a:t>Area</a:t>
+            </a:r>
+          </a:p>
+        </p:txBody>
+      </p:sp>
+      <p:sp>
+        <p:nvSpPr>
+          <p:cNvPr id="9" name="">
+            <a:extLst xmlns:a="http://schemas.openxmlformats.org/drawingml/2006/main">
+              <a:ext uri="{FF2B5EF4-FFF2-40B4-BE49-F238E27FC236}">
+                <a16:creationId xmlns:a16="http://schemas.microsoft.com/office/drawing/2014/main" id="{853CF45E-8AC3-4CBC-9966-EDD9535FFF70}"/>
+              </a:ext>
+            </a:extLst>
+          </p:cNvPr>
+          <p:cNvSpPr>
+            <a:spLocks xmlns:a="http://schemas.openxmlformats.org/drawingml/2006/main" noGrp="1"/>
+          </p:cNvSpPr>
+          <p:nvPr/>
+        </p:nvSpPr>
+        <p:spPr>
+          <a:xfrm xmlns:a="http://schemas.openxmlformats.org/drawingml/2006/main">
+            <a:off x="3333750" y="5534025"/>
+            <a:ext cx="2381250" cy="685800"/>
+          </a:xfrm>
+          <a:prstGeom xmlns:a="http://schemas.openxmlformats.org/drawingml/2006/main" prst="rect">
+            <a:avLst/>
+          </a:prstGeom>
+          <a:noFill xmlns:a="http://schemas.openxmlformats.org/drawingml/2006/main"/>
+          <a:ln xmlns:a="http://schemas.openxmlformats.org/drawingml/2006/main" w="0">
+            <a:noFill/>
+          </a:ln>
+        </p:spPr>
+        <p:txBody>
+          <a:bodyPr xmlns:a="http://schemas.openxmlformats.org/drawingml/2006/main" lIns="0" tIns="0" rIns="0" bIns="0"/>
+          <a:lstStyle xmlns:a="http://schemas.openxmlformats.org/drawingml/2006/main">
+            <a:defPPr algn="ctr">
+              <a:defRPr sz="1875">
+                <a:solidFill>
+                  <a:srgbClr val="81796F"/>
+                </a:solidFill>
+                <a:latin typeface="Ubuntu Condensed"/>
+                <a:ea typeface="Ubuntu Condensed"/>
+                <a:cs typeface="Ubuntu Condensed"/>
+              </a:defRPr>
+            </a:defPPr>
+          </a:lstStyle>
+          <a:p xmlns:a="http://schemas.openxmlformats.org/drawingml/2006/main">
+            <a:pPr algn="ctr">
+              <a:defRPr sz="1875">
+                <a:solidFill>
+                  <a:srgbClr val="81796F"/>
+                </a:solidFill>
+                <a:latin typeface="Ubuntu Condensed"/>
+                <a:ea typeface="Ubuntu Condensed"/>
+                <a:cs typeface="Ubuntu Condensed"/>
+              </a:defRPr>
+            </a:pPr>
+            <a:r>
+              <a:rPr sz="1875">
+                <a:solidFill>
+                  <a:srgbClr val="81796F"/>
+                </a:solidFill>
+                <a:latin typeface="Ubuntu Condensed"/>
+                <a:ea typeface="Ubuntu Condensed"/>
+                <a:cs typeface="Ubuntu Condensed"/>
+              </a:rPr>
+              <a:t>Population</a:t>
+            </a:r>
+          </a:p>
+        </p:txBody>
+      </p:sp>
+      <p:sp>
+        <p:nvSpPr>
+          <p:cNvPr id="10" name="">
+            <a:extLst xmlns:a="http://schemas.openxmlformats.org/drawingml/2006/main">
+              <a:ext uri="{FF2B5EF4-FFF2-40B4-BE49-F238E27FC236}">
+                <a16:creationId xmlns:a16="http://schemas.microsoft.com/office/drawing/2014/main" id="{A1116662-9507-48C1-BC95-889539BEC198}"/>
+              </a:ext>
+            </a:extLst>
+          </p:cNvPr>
+          <p:cNvSpPr>
+            <a:spLocks xmlns:a="http://schemas.openxmlformats.org/drawingml/2006/main" noGrp="1"/>
+          </p:cNvSpPr>
+          <p:nvPr/>
+        </p:nvSpPr>
+        <p:spPr>
+          <a:xfrm xmlns:a="http://schemas.openxmlformats.org/drawingml/2006/main">
+            <a:off x="6143625" y="5095875"/>
+            <a:ext cx="2381250" cy="381000"/>
+          </a:xfrm>
+          <a:prstGeom xmlns:a="http://schemas.openxmlformats.org/drawingml/2006/main" prst="rect">
+            <a:avLst/>
+          </a:prstGeom>
+          <a:noFill xmlns:a="http://schemas.openxmlformats.org/drawingml/2006/main"/>
+          <a:ln xmlns:a="http://schemas.openxmlformats.org/drawingml/2006/main" w="0">
+            <a:noFill/>
+          </a:ln>
+        </p:spPr>
+        <p:txBody>
+          <a:bodyPr xmlns:a="http://schemas.openxmlformats.org/drawingml/2006/main" lIns="0" tIns="0" rIns="0" bIns="0"/>
+          <a:lstStyle xmlns:a="http://schemas.openxmlformats.org/drawingml/2006/main">
+            <a:defPPr algn="ctr">
+              <a:defRPr sz="2325">
+                <a:solidFill>
+                  <a:srgbClr val="38332E"/>
+                </a:solidFill>
+                <a:latin typeface="Ubuntu Condensed"/>
+                <a:ea typeface="Ubuntu Condensed"/>
+                <a:cs typeface="Ubuntu Condensed"/>
+              </a:defRPr>
+            </a:defPPr>
+          </a:lstStyle>
+          <a:p xmlns:a="http://schemas.openxmlformats.org/drawingml/2006/main">
+            <a:pPr algn="ctr">
+              <a:defRPr sz="2325">
+                <a:solidFill>
+                  <a:srgbClr val="38332E"/>
+                </a:solidFill>
+                <a:latin typeface="Ubuntu Condensed"/>
+                <a:ea typeface="Ubuntu Condensed"/>
+                <a:cs typeface="Ubuntu Condensed"/>
+              </a:defRPr>
+            </a:pPr>
+            <a:r>
+              <a:rPr sz="2325">
+                <a:solidFill>
+                  <a:srgbClr val="38332E"/>
+                </a:solidFill>
+                <a:latin typeface="Ubuntu Condensed"/>
+                <a:ea typeface="Ubuntu Condensed"/>
+                <a:cs typeface="Ubuntu Condensed"/>
+              </a:rPr>
+              <a:t>Color</a:t>
+            </a:r>
+          </a:p>
+        </p:txBody>
+      </p:sp>
+      <p:sp>
+        <p:nvSpPr>
+          <p:cNvPr id="11" name="">
+            <a:extLst xmlns:a="http://schemas.openxmlformats.org/drawingml/2006/main">
+              <a:ext uri="{FF2B5EF4-FFF2-40B4-BE49-F238E27FC236}">
+                <a16:creationId xmlns:a16="http://schemas.microsoft.com/office/drawing/2014/main" id="{502D9C2A-90AC-428A-B894-8B121DFAC269}"/>
+              </a:ext>
+            </a:extLst>
+          </p:cNvPr>
+          <p:cNvSpPr>
+            <a:spLocks xmlns:a="http://schemas.openxmlformats.org/drawingml/2006/main" noGrp="1"/>
+          </p:cNvSpPr>
+          <p:nvPr/>
+        </p:nvSpPr>
+        <p:spPr>
+          <a:xfrm xmlns:a="http://schemas.openxmlformats.org/drawingml/2006/main">
+            <a:off x="6143625" y="5534025"/>
+            <a:ext cx="2381250" cy="685800"/>
+          </a:xfrm>
+          <a:prstGeom xmlns:a="http://schemas.openxmlformats.org/drawingml/2006/main" prst="rect">
+            <a:avLst/>
+          </a:prstGeom>
+          <a:noFill xmlns:a="http://schemas.openxmlformats.org/drawingml/2006/main"/>
+          <a:ln xmlns:a="http://schemas.openxmlformats.org/drawingml/2006/main" w="0">
+            <a:noFill/>
+          </a:ln>
+        </p:spPr>
+        <p:txBody>
+          <a:bodyPr xmlns:a="http://schemas.openxmlformats.org/drawingml/2006/main" lIns="0" tIns="0" rIns="0" bIns="0"/>
+          <a:lstStyle xmlns:a="http://schemas.openxmlformats.org/drawingml/2006/main">
+            <a:defPPr algn="ctr">
+              <a:defRPr sz="1875">
+                <a:solidFill>
+                  <a:srgbClr val="81796F"/>
+                </a:solidFill>
+                <a:latin typeface="Ubuntu Condensed"/>
+                <a:ea typeface="Ubuntu Condensed"/>
+                <a:cs typeface="Ubuntu Condensed"/>
+              </a:defRPr>
+            </a:defPPr>
+          </a:lstStyle>
+          <a:p xmlns:a="http://schemas.openxmlformats.org/drawingml/2006/main">
+            <a:pPr algn="ctr">
+              <a:defRPr sz="1875">
+                <a:solidFill>
+                  <a:srgbClr val="81796F"/>
+                </a:solidFill>
+                <a:latin typeface="Ubuntu Condensed"/>
+                <a:ea typeface="Ubuntu Condensed"/>
+                <a:cs typeface="Ubuntu Condensed"/>
+              </a:defRPr>
+            </a:pPr>
+            <a:r>
+              <a:rPr sz="1875">
+                <a:solidFill>
+                  <a:srgbClr val="81796F"/>
+                </a:solidFill>
+                <a:latin typeface="Ubuntu Condensed"/>
+                <a:ea typeface="Ubuntu Condensed"/>
+                <a:cs typeface="Ubuntu Condensed"/>
+              </a:rPr>
+              <a:t>Continent</a:t>
+            </a:r>
+          </a:p>
+        </p:txBody>
+      </p:sp>
+    </p:spTree>
+    <p:extLst>
+      <p:ext uri="{BB962C8B-B14F-4D97-AF65-F5344CB8AC3E}">
+        <p14:creationId xmlns:p14="http://schemas.microsoft.com/office/powerpoint/2010/main" val="1596242465"/>
+      </p:ext>
+    </p:extLst>
+  </p:cSld>
+</p:sld>
+</file>
+
+<file path=ppt/slides/slide4.xml><?xml version="1.0" encoding="utf-8"?>
+<p:sld xmlns:p="http://schemas.openxmlformats.org/presentationml/2006/main">
+  <p:cSld>
+    <p:bg>
+      <p:bgPr>
+        <a:solidFill xmlns:a="http://schemas.openxmlformats.org/drawingml/2006/main">
+          <a:srgbClr val="FFFFFF"/>
+        </a:solidFill>
+      </p:bgPr>
+    </p:bg>
+    <p:spTree>
+      <p:nvGrpSpPr>
+        <p:cNvPr id="1" name=""/>
+        <p:cNvGrpSpPr/>
+        <p:nvPr/>
+      </p:nvGrpSpPr>
+      <p:grpSpPr>
+        <a:xfrm xmlns:a="http://schemas.openxmlformats.org/drawingml/2006/main"/>
+      </p:grpSpPr>
+      <p:sp>
+        <p:nvSpPr>
+          <p:cNvPr id="19" name="">
+            <a:extLst xmlns:a="http://schemas.openxmlformats.org/drawingml/2006/main">
+              <a:ext uri="{FF2B5EF4-FFF2-40B4-BE49-F238E27FC236}">
+                <a16:creationId xmlns:a16="http://schemas.microsoft.com/office/drawing/2014/main" id="{B25BD5FA-7583-48E1-B88C-720130B7F20E}"/>
+              </a:ext>
+            </a:extLst>
+          </p:cNvPr>
+          <p:cNvSpPr>
+            <a:spLocks xmlns:a="http://schemas.openxmlformats.org/drawingml/2006/main" noGrp="1"/>
+          </p:cNvSpPr>
+          <p:nvPr/>
+        </p:nvSpPr>
+        <p:spPr>
+          <a:xfrm xmlns:a="http://schemas.openxmlformats.org/drawingml/2006/main">
+            <a:off x="457200" y="361950"/>
+            <a:ext cx="11277600" cy="628650"/>
+          </a:xfrm>
+          <a:prstGeom xmlns:a="http://schemas.openxmlformats.org/drawingml/2006/main" prst="rect">
+            <a:avLst/>
+          </a:prstGeom>
+          <a:noFill xmlns:a="http://schemas.openxmlformats.org/drawingml/2006/main"/>
+          <a:ln xmlns:a="http://schemas.openxmlformats.org/drawingml/2006/main" w="0">
+            <a:noFill/>
+          </a:ln>
+        </p:spPr>
+        <p:txBody>
+          <a:bodyPr xmlns:a="http://schemas.openxmlformats.org/drawingml/2006/main" lIns="0" tIns="0" rIns="0" bIns="0"/>
+          <a:lstStyle xmlns:a="http://schemas.openxmlformats.org/drawingml/2006/main">
+            <a:defPPr>
+              <a:defRPr sz="3600">
+                <a:solidFill>
+                  <a:srgbClr val="38332E"/>
+                </a:solidFill>
+                <a:latin typeface="Ubuntu Condensed"/>
+                <a:ea typeface="Ubuntu Condensed"/>
+                <a:cs typeface="Ubuntu Condensed"/>
+              </a:defRPr>
+            </a:defPPr>
+          </a:lstStyle>
+          <a:p xmlns:a="http://schemas.openxmlformats.org/drawingml/2006/main">
+            <a:pPr>
+              <a:defRPr sz="3600">
+                <a:solidFill>
+                  <a:srgbClr val="38332E"/>
+                </a:solidFill>
+                <a:latin typeface="Ubuntu Condensed"/>
+                <a:ea typeface="Ubuntu Condensed"/>
+                <a:cs typeface="Ubuntu Condensed"/>
+              </a:defRPr>
+            </a:pPr>
+            <a:r>
+              <a:rPr sz="3600">
+                <a:solidFill>
+                  <a:srgbClr val="38332E"/>
+                </a:solidFill>
+                <a:latin typeface="Ubuntu Condensed"/>
+                <a:ea typeface="Ubuntu Condensed"/>
+                <a:cs typeface="Ubuntu Condensed"/>
+              </a:rPr>
+              <a:t>What does a circle represent?</a:t>
+            </a:r>
+          </a:p>
+        </p:txBody>
+      </p:sp>
+      <p:sp>
+        <p:nvSpPr>
+          <p:cNvPr id="2" name="">
+            <a:extLst xmlns:a="http://schemas.openxmlformats.org/drawingml/2006/main">
+              <a:ext uri="{FF2B5EF4-FFF2-40B4-BE49-F238E27FC236}">
+                <a16:creationId xmlns:a16="http://schemas.microsoft.com/office/drawing/2014/main" id="{855B1DB8-5AE3-4EF9-B145-56CD1B21B70F}"/>
+              </a:ext>
+            </a:extLst>
+          </p:cNvPr>
+          <p:cNvSpPr>
+            <a:spLocks xmlns:a="http://schemas.openxmlformats.org/drawingml/2006/main" noGrp="1"/>
+          </p:cNvSpPr>
+          <p:nvPr/>
+        </p:nvSpPr>
+        <p:spPr>
+          <a:xfrm xmlns:a="http://schemas.openxmlformats.org/drawingml/2006/main">
+            <a:off x="457200" y="1085850"/>
+            <a:ext cx="11277600" cy="381000"/>
+          </a:xfrm>
+          <a:prstGeom xmlns:a="http://schemas.openxmlformats.org/drawingml/2006/main" prst="rect">
+            <a:avLst/>
+          </a:prstGeom>
+          <a:noFill xmlns:a="http://schemas.openxmlformats.org/drawingml/2006/main"/>
+          <a:ln xmlns:a="http://schemas.openxmlformats.org/drawingml/2006/main" w="0">
+            <a:noFill/>
+          </a:ln>
+        </p:spPr>
+        <p:txBody>
+          <a:bodyPr xmlns:a="http://schemas.openxmlformats.org/drawingml/2006/main" lIns="0" tIns="0" rIns="0" bIns="0"/>
+          <a:lstStyle xmlns:a="http://schemas.openxmlformats.org/drawingml/2006/main">
+            <a:defPPr>
+              <a:defRPr sz="2025">
+                <a:solidFill>
+                  <a:srgbClr val="81796F"/>
+                </a:solidFill>
+                <a:latin typeface="Ubuntu Condensed"/>
+                <a:ea typeface="Ubuntu Condensed"/>
+                <a:cs typeface="Ubuntu Condensed"/>
+              </a:defRPr>
+            </a:defPPr>
+          </a:lstStyle>
+          <a:p xmlns:a="http://schemas.openxmlformats.org/drawingml/2006/main">
+            <a:pPr>
+              <a:defRPr sz="2025">
+                <a:solidFill>
+                  <a:srgbClr val="81796F"/>
+                </a:solidFill>
+                <a:latin typeface="Ubuntu Condensed"/>
+                <a:ea typeface="Ubuntu Condensed"/>
+                <a:cs typeface="Ubuntu Condensed"/>
+              </a:defRPr>
+            </a:pPr>
+            <a:r>
+              <a:rPr sz="2025">
+                <a:solidFill>
+                  <a:srgbClr val="81796F"/>
+                </a:solidFill>
+                <a:latin typeface="Ubuntu Condensed"/>
+                <a:ea typeface="Ubuntu Condensed"/>
+                <a:cs typeface="Ubuntu Condensed"/>
+              </a:rPr>
+              <a:t>Gapminder: one country, one year</a:t>
+            </a:r>
+          </a:p>
+        </p:txBody>
+      </p:sp>
+      <p:sp>
+        <p:nvSpPr>
+          <p:cNvPr id="3" name="">
+            <a:extLst xmlns:a="http://schemas.openxmlformats.org/drawingml/2006/main">
+              <a:ext uri="{FF2B5EF4-FFF2-40B4-BE49-F238E27FC236}">
+                <a16:creationId xmlns:a16="http://schemas.microsoft.com/office/drawing/2014/main" id="{77F63239-D686-4A02-B2A3-BCE0490319D2}"/>
+              </a:ext>
+            </a:extLst>
+          </p:cNvPr>
+          <p:cNvSpPr>
+            <a:spLocks xmlns:a="http://schemas.openxmlformats.org/drawingml/2006/main" noGrp="1"/>
+          </p:cNvSpPr>
+          <p:nvPr/>
+        </p:nvSpPr>
+        <p:spPr>
+          <a:xfrm xmlns:a="http://schemas.openxmlformats.org/drawingml/2006/main">
+            <a:off x="1504950" y="3028950"/>
+            <a:ext cx="419100" cy="419100"/>
+          </a:xfrm>
+          <a:prstGeom xmlns:a="http://schemas.openxmlformats.org/drawingml/2006/main" prst="ellipse">
+            <a:avLst/>
+          </a:prstGeom>
+          <a:solidFill xmlns:a="http://schemas.openxmlformats.org/drawingml/2006/main">
+            <a:srgbClr val="A6A29C"/>
+          </a:solidFill>
+          <a:ln xmlns:a="http://schemas.openxmlformats.org/drawingml/2006/main" w="0">
+            <a:noFill/>
+          </a:ln>
+        </p:spPr>
+      </p:sp>
+      <p:sp>
+        <p:nvSpPr>
+          <p:cNvPr id="4" name="">
+            <a:extLst xmlns:a="http://schemas.openxmlformats.org/drawingml/2006/main">
+              <a:ext uri="{FF2B5EF4-FFF2-40B4-BE49-F238E27FC236}">
+                <a16:creationId xmlns:a16="http://schemas.microsoft.com/office/drawing/2014/main" id="{395B129A-0775-4C58-8313-F43475088E06}"/>
+              </a:ext>
+            </a:extLst>
+          </p:cNvPr>
+          <p:cNvSpPr>
+            <a:spLocks xmlns:a="http://schemas.openxmlformats.org/drawingml/2006/main" noGrp="1"/>
+          </p:cNvSpPr>
+          <p:nvPr/>
+        </p:nvSpPr>
+        <p:spPr>
+          <a:xfrm xmlns:a="http://schemas.openxmlformats.org/drawingml/2006/main">
+            <a:off x="4019550" y="2781300"/>
+            <a:ext cx="914400" cy="914400"/>
+          </a:xfrm>
+          <a:prstGeom xmlns:a="http://schemas.openxmlformats.org/drawingml/2006/main" prst="ellipse">
+            <a:avLst/>
+          </a:prstGeom>
+          <a:solidFill xmlns:a="http://schemas.openxmlformats.org/drawingml/2006/main">
+            <a:srgbClr val="A6A29C"/>
+          </a:solidFill>
+          <a:ln xmlns:a="http://schemas.openxmlformats.org/drawingml/2006/main" w="0">
+            <a:noFill/>
+          </a:ln>
+        </p:spPr>
+      </p:sp>
+      <p:sp>
+        <p:nvSpPr>
+          <p:cNvPr id="5" name="">
+            <a:extLst xmlns:a="http://schemas.openxmlformats.org/drawingml/2006/main">
+              <a:ext uri="{FF2B5EF4-FFF2-40B4-BE49-F238E27FC236}">
+                <a16:creationId xmlns:a16="http://schemas.microsoft.com/office/drawing/2014/main" id="{81319144-7903-417D-9EB2-5C7F023FCBB4}"/>
+              </a:ext>
+            </a:extLst>
+          </p:cNvPr>
+          <p:cNvSpPr>
+            <a:spLocks xmlns:a="http://schemas.openxmlformats.org/drawingml/2006/main" noGrp="1"/>
+          </p:cNvSpPr>
+          <p:nvPr/>
+        </p:nvSpPr>
+        <p:spPr>
+          <a:xfrm xmlns:a="http://schemas.openxmlformats.org/drawingml/2006/main">
+            <a:off x="6781800" y="2781300"/>
+            <a:ext cx="914400" cy="914400"/>
+          </a:xfrm>
+          <a:prstGeom xmlns:a="http://schemas.openxmlformats.org/drawingml/2006/main" prst="ellipse">
+            <a:avLst/>
+          </a:prstGeom>
+          <a:solidFill xmlns:a="http://schemas.openxmlformats.org/drawingml/2006/main">
+            <a:srgbClr val="B23C50"/>
+          </a:solidFill>
+          <a:ln xmlns:a="http://schemas.openxmlformats.org/drawingml/2006/main" w="0">
+            <a:noFill/>
+          </a:ln>
+        </p:spPr>
+      </p:sp>
+      <p:sp>
+        <p:nvSpPr>
+          <p:cNvPr id="6" name="">
+            <a:extLst xmlns:a="http://schemas.openxmlformats.org/drawingml/2006/main">
+              <a:ext uri="{FF2B5EF4-FFF2-40B4-BE49-F238E27FC236}">
+                <a16:creationId xmlns:a16="http://schemas.microsoft.com/office/drawing/2014/main" id="{6BE942EE-C8C8-41A3-907B-3EE434871C51}"/>
               </a:ext>
             </a:extLst>
           </p:cNvPr>
@@ -2973,7 +4641,7 @@
           <p:cNvPr id="7" name="">
             <a:extLst xmlns:a="http://schemas.openxmlformats.org/drawingml/2006/main">
               <a:ext uri="{FF2B5EF4-FFF2-40B4-BE49-F238E27FC236}">
-                <a16:creationId xmlns:a16="http://schemas.microsoft.com/office/drawing/2014/main" id="{20124902-43D4-4BD9-AE6C-4098AC686FC8}"/>
+                <a16:creationId xmlns:a16="http://schemas.microsoft.com/office/drawing/2014/main" id="{63A93DC4-67E3-4317-838A-A29207ED5DFC}"/>
               </a:ext>
             </a:extLst>
           </p:cNvPr>
@@ -3003,7 +4671,7 @@
           <p:cNvPr id="8" name="">
             <a:extLst xmlns:a="http://schemas.openxmlformats.org/drawingml/2006/main">
               <a:ext uri="{FF2B5EF4-FFF2-40B4-BE49-F238E27FC236}">
-                <a16:creationId xmlns:a16="http://schemas.microsoft.com/office/drawing/2014/main" id="{59F824E4-E67B-4A3A-8716-EEBCB7C430CB}"/>
+                <a16:creationId xmlns:a16="http://schemas.microsoft.com/office/drawing/2014/main" id="{83516ECD-ECDA-4CE1-B1C5-14B9DDFD5A21}"/>
               </a:ext>
             </a:extLst>
           </p:cNvPr>
@@ -3069,7 +4737,7 @@
           <p:cNvPr id="9" name="">
             <a:extLst xmlns:a="http://schemas.openxmlformats.org/drawingml/2006/main">
               <a:ext uri="{FF2B5EF4-FFF2-40B4-BE49-F238E27FC236}">
-                <a16:creationId xmlns:a16="http://schemas.microsoft.com/office/drawing/2014/main" id="{F10C751B-B70F-4CA7-B8AB-1186F5F674C5}"/>
+                <a16:creationId xmlns:a16="http://schemas.microsoft.com/office/drawing/2014/main" id="{4C060D88-CA3E-4D47-8D31-F742FF123A52}"/>
               </a:ext>
             </a:extLst>
           </p:cNvPr>
@@ -3135,7 +4803,7 @@
           <p:cNvPr id="10" name="">
             <a:extLst xmlns:a="http://schemas.openxmlformats.org/drawingml/2006/main">
               <a:ext uri="{FF2B5EF4-FFF2-40B4-BE49-F238E27FC236}">
-                <a16:creationId xmlns:a16="http://schemas.microsoft.com/office/drawing/2014/main" id="{7ED5B10A-1013-45DA-948F-5F9AD03D3558}"/>
+                <a16:creationId xmlns:a16="http://schemas.microsoft.com/office/drawing/2014/main" id="{937C93D1-6083-4BCF-8722-679EE0EEF532}"/>
               </a:ext>
             </a:extLst>
           </p:cNvPr>
@@ -3165,7 +4833,7 @@
           <p:cNvPr id="11" name="">
             <a:extLst xmlns:a="http://schemas.openxmlformats.org/drawingml/2006/main">
               <a:ext uri="{FF2B5EF4-FFF2-40B4-BE49-F238E27FC236}">
-                <a16:creationId xmlns:a16="http://schemas.microsoft.com/office/drawing/2014/main" id="{6BE702B6-8E3F-407B-AFE3-57469CA69498}"/>
+                <a16:creationId xmlns:a16="http://schemas.microsoft.com/office/drawing/2014/main" id="{13131CF8-2BA0-490F-9282-0A92C5E71BB9}"/>
               </a:ext>
             </a:extLst>
           </p:cNvPr>
@@ -3231,7 +4899,7 @@
           <p:cNvPr id="12" name="">
             <a:extLst xmlns:a="http://schemas.openxmlformats.org/drawingml/2006/main">
               <a:ext uri="{FF2B5EF4-FFF2-40B4-BE49-F238E27FC236}">
-                <a16:creationId xmlns:a16="http://schemas.microsoft.com/office/drawing/2014/main" id="{6B8A2187-FCAA-4010-AA03-87F9EC73000A}"/>
+                <a16:creationId xmlns:a16="http://schemas.microsoft.com/office/drawing/2014/main" id="{A0EC0C12-5916-4F02-87B9-DD50B92BF2FB}"/>
               </a:ext>
             </a:extLst>
           </p:cNvPr>
@@ -3297,7 +4965,7 @@
           <p:cNvPr id="13" name="">
             <a:extLst xmlns:a="http://schemas.openxmlformats.org/drawingml/2006/main">
               <a:ext uri="{FF2B5EF4-FFF2-40B4-BE49-F238E27FC236}">
-                <a16:creationId xmlns:a16="http://schemas.microsoft.com/office/drawing/2014/main" id="{41A1F75C-16B6-4A6A-A107-2997D8010433}"/>
+                <a16:creationId xmlns:a16="http://schemas.microsoft.com/office/drawing/2014/main" id="{95B159A7-1212-431F-A142-095D280E985B}"/>
               </a:ext>
             </a:extLst>
           </p:cNvPr>
@@ -3363,7 +5031,7 @@
           <p:cNvPr id="14" name="">
             <a:extLst xmlns:a="http://schemas.openxmlformats.org/drawingml/2006/main">
               <a:ext uri="{FF2B5EF4-FFF2-40B4-BE49-F238E27FC236}">
-                <a16:creationId xmlns:a16="http://schemas.microsoft.com/office/drawing/2014/main" id="{6D9EF904-5ECE-4843-B5B4-9F3F31265378}"/>
+                <a16:creationId xmlns:a16="http://schemas.microsoft.com/office/drawing/2014/main" id="{DBB6EB5B-0784-4179-BE76-C5244EA2317C}"/>
               </a:ext>
             </a:extLst>
           </p:cNvPr>
@@ -3429,7 +5097,7 @@
           <p:cNvPr id="15" name="">
             <a:extLst xmlns:a="http://schemas.openxmlformats.org/drawingml/2006/main">
               <a:ext uri="{FF2B5EF4-FFF2-40B4-BE49-F238E27FC236}">
-                <a16:creationId xmlns:a16="http://schemas.microsoft.com/office/drawing/2014/main" id="{9ABB4E63-D92D-48F6-9909-067EAF020A5C}"/>
+                <a16:creationId xmlns:a16="http://schemas.microsoft.com/office/drawing/2014/main" id="{D7E028CB-1E6E-4C7F-B916-A37C53CDAE3C}"/>
               </a:ext>
             </a:extLst>
           </p:cNvPr>
@@ -3495,7 +5163,7 @@
           <p:cNvPr id="16" name="">
             <a:extLst xmlns:a="http://schemas.openxmlformats.org/drawingml/2006/main">
               <a:ext uri="{FF2B5EF4-FFF2-40B4-BE49-F238E27FC236}">
-                <a16:creationId xmlns:a16="http://schemas.microsoft.com/office/drawing/2014/main" id="{C5694335-9A70-475C-89B3-159711142025}"/>
+                <a16:creationId xmlns:a16="http://schemas.microsoft.com/office/drawing/2014/main" id="{B1E7E5C7-3BE1-49D2-AED1-6E104D6F285A}"/>
               </a:ext>
             </a:extLst>
           </p:cNvPr>
@@ -3561,7 +5229,7 @@
           <p:cNvPr id="17" name="">
             <a:extLst xmlns:a="http://schemas.openxmlformats.org/drawingml/2006/main">
               <a:ext uri="{FF2B5EF4-FFF2-40B4-BE49-F238E27FC236}">
-                <a16:creationId xmlns:a16="http://schemas.microsoft.com/office/drawing/2014/main" id="{CFE6DD74-E9A8-4063-A9BA-944915C59214}"/>
+                <a16:creationId xmlns:a16="http://schemas.microsoft.com/office/drawing/2014/main" id="{10506556-04F9-4130-8248-DF9A7E15E971}"/>
               </a:ext>
             </a:extLst>
           </p:cNvPr>
@@ -3627,7 +5295,7 @@
           <p:cNvPr id="18" name="">
             <a:extLst xmlns:a="http://schemas.openxmlformats.org/drawingml/2006/main">
               <a:ext uri="{FF2B5EF4-FFF2-40B4-BE49-F238E27FC236}">
-                <a16:creationId xmlns:a16="http://schemas.microsoft.com/office/drawing/2014/main" id="{39868516-9EE9-4EA6-B39D-D83FA279FF62}"/>
+                <a16:creationId xmlns:a16="http://schemas.microsoft.com/office/drawing/2014/main" id="{312A955F-BB21-488E-991C-9C60D47BAD53}"/>
               </a:ext>
             </a:extLst>
           </p:cNvPr>
@@ -3691,7 +5359,7 @@
     </p:spTree>
     <p:extLst>
       <p:ext uri="{BB962C8B-B14F-4D97-AF65-F5344CB8AC3E}">
-        <p14:creationId xmlns:p14="http://schemas.microsoft.com/office/powerpoint/2010/main" val="523849170"/>
+        <p14:creationId xmlns:p14="http://schemas.microsoft.com/office/powerpoint/2010/main" val="555456237"/>
       </p:ext>
     </p:extLst>
   </p:cSld>

</xml_diff>